<commit_message>
add project name to footer
</commit_message>
<xml_diff>
--- a/Interim.pptx
+++ b/Interim.pptx
@@ -2302,9 +2302,10 @@
           <a:lstStyle/>
           <a:p>
             <a:r>
-              <a:rPr lang="en-GB"/>
+              <a:rPr lang="en-US"/>
               <a:t>11/03/2026</a:t>
             </a:r>
+            <a:endParaRPr lang="en-GB"/>
           </a:p>
         </p:txBody>
       </p:sp>
@@ -2329,6 +2330,10 @@
           <a:bodyPr/>
           <a:lstStyle/>
           <a:p>
+            <a:r>
+              <a:rPr lang="en-GB"/>
+              <a:t>Project LRC001 – Paul Kallarackel - 02029025</a:t>
+            </a:r>
             <a:endParaRPr lang="en-GB" dirty="0"/>
           </a:p>
         </p:txBody>
@@ -2606,9 +2611,10 @@
           <a:lstStyle/>
           <a:p>
             <a:r>
-              <a:rPr lang="en-GB"/>
+              <a:rPr lang="en-US"/>
               <a:t>11/03/2026</a:t>
             </a:r>
+            <a:endParaRPr lang="en-GB"/>
           </a:p>
         </p:txBody>
       </p:sp>
@@ -2633,6 +2639,10 @@
           <a:bodyPr/>
           <a:lstStyle/>
           <a:p>
+            <a:r>
+              <a:rPr lang="en-GB"/>
+              <a:t>Project LRC001 – Paul Kallarackel - 02029025</a:t>
+            </a:r>
             <a:endParaRPr lang="en-GB" dirty="0"/>
           </a:p>
         </p:txBody>
@@ -2910,9 +2920,10 @@
           <a:lstStyle/>
           <a:p>
             <a:r>
-              <a:rPr lang="en-GB"/>
+              <a:rPr lang="en-US"/>
               <a:t>11/03/2026</a:t>
             </a:r>
+            <a:endParaRPr lang="en-GB"/>
           </a:p>
         </p:txBody>
       </p:sp>
@@ -2937,6 +2948,10 @@
           <a:bodyPr/>
           <a:lstStyle/>
           <a:p>
+            <a:r>
+              <a:rPr lang="en-GB"/>
+              <a:t>Project LRC001 – Paul Kallarackel - 02029025</a:t>
+            </a:r>
             <a:endParaRPr lang="en-GB" dirty="0"/>
           </a:p>
         </p:txBody>
@@ -3265,9 +3280,10 @@
           <a:lstStyle/>
           <a:p>
             <a:r>
-              <a:rPr lang="en-GB"/>
+              <a:rPr lang="en-US"/>
               <a:t>11/03/2026</a:t>
             </a:r>
+            <a:endParaRPr lang="en-GB"/>
           </a:p>
         </p:txBody>
       </p:sp>
@@ -3292,7 +3308,10 @@
           <a:bodyPr/>
           <a:lstStyle/>
           <a:p>
-            <a:endParaRPr lang="en-GB"/>
+            <a:r>
+              <a:rPr lang="en-GB"/>
+              <a:t>Project LRC001 – Paul Kallarackel - 02029025</a:t>
+            </a:r>
           </a:p>
         </p:txBody>
       </p:sp>
@@ -3628,9 +3647,10 @@
           <a:lstStyle/>
           <a:p>
             <a:r>
-              <a:rPr lang="en-GB"/>
+              <a:rPr lang="en-US"/>
               <a:t>11/03/2026</a:t>
             </a:r>
+            <a:endParaRPr lang="en-GB"/>
           </a:p>
         </p:txBody>
       </p:sp>
@@ -3655,7 +3675,10 @@
           <a:bodyPr/>
           <a:lstStyle/>
           <a:p>
-            <a:endParaRPr lang="en-GB"/>
+            <a:r>
+              <a:rPr lang="en-GB"/>
+              <a:t>Project LRC001 – Paul Kallarackel - 02029025</a:t>
+            </a:r>
           </a:p>
         </p:txBody>
       </p:sp>
@@ -3991,9 +4014,10 @@
           <a:lstStyle/>
           <a:p>
             <a:r>
-              <a:rPr lang="en-GB"/>
+              <a:rPr lang="en-US"/>
               <a:t>11/03/2026</a:t>
             </a:r>
+            <a:endParaRPr lang="en-GB"/>
           </a:p>
         </p:txBody>
       </p:sp>
@@ -4018,7 +4042,10 @@
           <a:bodyPr/>
           <a:lstStyle/>
           <a:p>
-            <a:endParaRPr lang="en-GB"/>
+            <a:r>
+              <a:rPr lang="en-GB"/>
+              <a:t>Project LRC001 – Paul Kallarackel - 02029025</a:t>
+            </a:r>
           </a:p>
         </p:txBody>
       </p:sp>
@@ -4214,9 +4241,10 @@
           <a:lstStyle/>
           <a:p>
             <a:r>
-              <a:rPr lang="en-GB"/>
+              <a:rPr lang="en-US"/>
               <a:t>11/03/2026</a:t>
             </a:r>
+            <a:endParaRPr lang="en-GB"/>
           </a:p>
         </p:txBody>
       </p:sp>
@@ -4241,6 +4269,10 @@
           <a:bodyPr/>
           <a:lstStyle/>
           <a:p>
+            <a:r>
+              <a:rPr lang="en-GB"/>
+              <a:t>Project LRC001 – Paul Kallarackel - 02029025</a:t>
+            </a:r>
             <a:endParaRPr lang="en-GB" dirty="0"/>
           </a:p>
         </p:txBody>
@@ -4683,9 +4715,10 @@
           <a:lstStyle/>
           <a:p>
             <a:r>
-              <a:rPr lang="en-GB"/>
+              <a:rPr lang="en-US"/>
               <a:t>11/03/2026</a:t>
             </a:r>
+            <a:endParaRPr lang="en-GB"/>
           </a:p>
         </p:txBody>
       </p:sp>
@@ -4710,6 +4743,10 @@
           <a:bodyPr/>
           <a:lstStyle/>
           <a:p>
+            <a:r>
+              <a:rPr lang="en-GB"/>
+              <a:t>Project LRC001 – Paul Kallarackel - 02029025</a:t>
+            </a:r>
             <a:endParaRPr lang="en-GB" dirty="0"/>
           </a:p>
         </p:txBody>
@@ -5152,9 +5189,10 @@
           <a:lstStyle/>
           <a:p>
             <a:r>
-              <a:rPr lang="en-GB"/>
+              <a:rPr lang="en-US"/>
               <a:t>11/03/2026</a:t>
             </a:r>
+            <a:endParaRPr lang="en-GB"/>
           </a:p>
         </p:txBody>
       </p:sp>
@@ -5179,6 +5217,10 @@
           <a:bodyPr/>
           <a:lstStyle/>
           <a:p>
+            <a:r>
+              <a:rPr lang="en-GB"/>
+              <a:t>Project LRC001 – Paul Kallarackel - 02029025</a:t>
+            </a:r>
             <a:endParaRPr lang="en-GB" dirty="0"/>
           </a:p>
         </p:txBody>
@@ -5614,9 +5656,10 @@
           <a:lstStyle/>
           <a:p>
             <a:r>
-              <a:rPr lang="en-GB"/>
+              <a:rPr lang="en-US"/>
               <a:t>11/03/2026</a:t>
             </a:r>
+            <a:endParaRPr lang="en-GB"/>
           </a:p>
         </p:txBody>
       </p:sp>
@@ -5641,6 +5684,10 @@
           <a:bodyPr/>
           <a:lstStyle/>
           <a:p>
+            <a:r>
+              <a:rPr lang="en-GB"/>
+              <a:t>Project LRC001 – Paul Kallarackel - 02029025</a:t>
+            </a:r>
             <a:endParaRPr lang="en-GB" dirty="0"/>
           </a:p>
         </p:txBody>
@@ -7869,9 +7916,10 @@
           <a:lstStyle/>
           <a:p>
             <a:r>
-              <a:rPr lang="en-GB"/>
+              <a:rPr lang="en-US"/>
               <a:t>11/03/2026</a:t>
             </a:r>
+            <a:endParaRPr lang="en-GB"/>
           </a:p>
         </p:txBody>
       </p:sp>
@@ -7896,6 +7944,10 @@
           <a:bodyPr/>
           <a:lstStyle/>
           <a:p>
+            <a:r>
+              <a:rPr lang="en-GB"/>
+              <a:t>Project LRC001 – Paul Kallarackel - 02029025</a:t>
+            </a:r>
             <a:endParaRPr lang="en-GB" dirty="0"/>
           </a:p>
         </p:txBody>
@@ -8453,9 +8505,10 @@
           <a:lstStyle/>
           <a:p>
             <a:r>
-              <a:rPr lang="en-GB"/>
+              <a:rPr lang="en-US"/>
               <a:t>11/03/2026</a:t>
             </a:r>
+            <a:endParaRPr lang="en-GB"/>
           </a:p>
         </p:txBody>
       </p:sp>
@@ -8480,6 +8533,10 @@
           <a:bodyPr/>
           <a:lstStyle/>
           <a:p>
+            <a:r>
+              <a:rPr lang="en-GB"/>
+              <a:t>Project LRC001 – Paul Kallarackel - 02029025</a:t>
+            </a:r>
             <a:endParaRPr lang="en-GB" dirty="0"/>
           </a:p>
         </p:txBody>
@@ -9038,9 +9095,10 @@
           <a:lstStyle/>
           <a:p>
             <a:r>
-              <a:rPr lang="en-GB"/>
+              <a:rPr lang="en-US"/>
               <a:t>11/03/2026</a:t>
             </a:r>
+            <a:endParaRPr lang="en-GB"/>
           </a:p>
         </p:txBody>
       </p:sp>
@@ -9065,6 +9123,10 @@
           <a:bodyPr/>
           <a:lstStyle/>
           <a:p>
+            <a:r>
+              <a:rPr lang="en-GB"/>
+              <a:t>Project LRC001 – Paul Kallarackel - 02029025</a:t>
+            </a:r>
             <a:endParaRPr lang="en-GB" dirty="0"/>
           </a:p>
         </p:txBody>
@@ -9200,9 +9262,10 @@
           <a:lstStyle/>
           <a:p>
             <a:r>
-              <a:rPr lang="en-GB"/>
+              <a:rPr lang="en-US"/>
               <a:t>11/03/2026</a:t>
             </a:r>
+            <a:endParaRPr lang="en-GB"/>
           </a:p>
         </p:txBody>
       </p:sp>
@@ -9227,6 +9290,10 @@
           <a:bodyPr/>
           <a:lstStyle/>
           <a:p>
+            <a:r>
+              <a:rPr lang="en-GB"/>
+              <a:t>Project LRC001 – Paul Kallarackel - 02029025</a:t>
+            </a:r>
             <a:endParaRPr lang="en-GB" dirty="0"/>
           </a:p>
         </p:txBody>
@@ -9362,9 +9429,10 @@
           <a:lstStyle/>
           <a:p>
             <a:r>
-              <a:rPr lang="en-GB"/>
+              <a:rPr lang="en-US"/>
               <a:t>11/03/2026</a:t>
             </a:r>
+            <a:endParaRPr lang="en-GB"/>
           </a:p>
         </p:txBody>
       </p:sp>
@@ -9389,6 +9457,10 @@
           <a:bodyPr/>
           <a:lstStyle/>
           <a:p>
+            <a:r>
+              <a:rPr lang="en-GB"/>
+              <a:t>Project LRC001 – Paul Kallarackel - 02029025</a:t>
+            </a:r>
             <a:endParaRPr lang="en-GB" dirty="0"/>
           </a:p>
         </p:txBody>
@@ -9536,9 +9608,10 @@
           </a:lstStyle>
           <a:p>
             <a:r>
-              <a:rPr lang="en-GB"/>
+              <a:rPr lang="en-US"/>
               <a:t>11/03/2026</a:t>
             </a:r>
+            <a:endParaRPr lang="en-GB"/>
           </a:p>
         </p:txBody>
       </p:sp>
@@ -9571,6 +9644,10 @@
             </a:lvl1pPr>
           </a:lstStyle>
           <a:p>
+            <a:r>
+              <a:rPr lang="en-GB"/>
+              <a:t>Project LRC001 – Paul Kallarackel - 02029025</a:t>
+            </a:r>
             <a:endParaRPr lang="en-GB" dirty="0"/>
           </a:p>
         </p:txBody>
@@ -9717,9 +9794,10 @@
           <a:lstStyle/>
           <a:p>
             <a:r>
-              <a:rPr lang="en-GB"/>
+              <a:rPr lang="en-US"/>
               <a:t>11/03/2026</a:t>
             </a:r>
+            <a:endParaRPr lang="en-GB"/>
           </a:p>
         </p:txBody>
       </p:sp>
@@ -9744,6 +9822,10 @@
           <a:bodyPr/>
           <a:lstStyle/>
           <a:p>
+            <a:r>
+              <a:rPr lang="en-GB"/>
+              <a:t>Project LRC001 – Paul Kallarackel - 02029025</a:t>
+            </a:r>
             <a:endParaRPr lang="en-GB" dirty="0"/>
           </a:p>
         </p:txBody>
@@ -9960,9 +10042,10 @@
           <a:lstStyle/>
           <a:p>
             <a:r>
-              <a:rPr lang="en-GB"/>
+              <a:rPr lang="en-US"/>
               <a:t>11/03/2026</a:t>
             </a:r>
+            <a:endParaRPr lang="en-GB"/>
           </a:p>
         </p:txBody>
       </p:sp>
@@ -9987,6 +10070,10 @@
           <a:bodyPr/>
           <a:lstStyle/>
           <a:p>
+            <a:r>
+              <a:rPr lang="en-GB"/>
+              <a:t>Project LRC001 – Paul Kallarackel - 02029025</a:t>
+            </a:r>
             <a:endParaRPr lang="en-GB" dirty="0"/>
           </a:p>
         </p:txBody>
@@ -10203,9 +10290,10 @@
           <a:lstStyle/>
           <a:p>
             <a:r>
-              <a:rPr lang="en-GB"/>
+              <a:rPr lang="en-US"/>
               <a:t>11/03/2026</a:t>
             </a:r>
+            <a:endParaRPr lang="en-GB"/>
           </a:p>
         </p:txBody>
       </p:sp>
@@ -10230,6 +10318,10 @@
           <a:bodyPr/>
           <a:lstStyle/>
           <a:p>
+            <a:r>
+              <a:rPr lang="en-GB"/>
+              <a:t>Project LRC001 – Paul Kallarackel - 02029025</a:t>
+            </a:r>
             <a:endParaRPr lang="en-GB" dirty="0"/>
           </a:p>
         </p:txBody>
@@ -10454,9 +10546,10 @@
           </a:lstStyle>
           <a:p>
             <a:r>
-              <a:rPr lang="en-GB"/>
+              <a:rPr lang="en-US"/>
               <a:t>11/03/2026</a:t>
             </a:r>
+            <a:endParaRPr lang="en-GB"/>
           </a:p>
         </p:txBody>
       </p:sp>
@@ -10489,6 +10582,10 @@
             </a:lvl1pPr>
           </a:lstStyle>
           <a:p>
+            <a:r>
+              <a:rPr lang="en-GB"/>
+              <a:t>Project LRC001 – Paul Kallarackel - 02029025</a:t>
+            </a:r>
             <a:endParaRPr lang="en-GB" dirty="0"/>
           </a:p>
         </p:txBody>
@@ -12417,9 +12514,10 @@
           <a:lstStyle/>
           <a:p>
             <a:r>
-              <a:rPr lang="en-GB"/>
+              <a:rPr lang="en-US"/>
               <a:t>11/03/2026</a:t>
             </a:r>
+            <a:endParaRPr lang="en-GB"/>
           </a:p>
         </p:txBody>
       </p:sp>
@@ -12444,6 +12542,10 @@
           <a:bodyPr/>
           <a:lstStyle/>
           <a:p>
+            <a:r>
+              <a:rPr lang="en-GB"/>
+              <a:t>Project LRC001 – Paul Kallarackel - 02029025</a:t>
+            </a:r>
             <a:endParaRPr lang="en-GB" dirty="0"/>
           </a:p>
         </p:txBody>
@@ -12784,9 +12886,10 @@
           <a:lstStyle/>
           <a:p>
             <a:r>
-              <a:rPr lang="en-GB"/>
+              <a:rPr lang="en-US"/>
               <a:t>11/03/2026</a:t>
             </a:r>
+            <a:endParaRPr lang="en-GB"/>
           </a:p>
         </p:txBody>
       </p:sp>
@@ -12811,6 +12914,10 @@
           <a:bodyPr/>
           <a:lstStyle/>
           <a:p>
+            <a:r>
+              <a:rPr lang="en-GB"/>
+              <a:t>Project LRC001 – Paul Kallarackel - 02029025</a:t>
+            </a:r>
             <a:endParaRPr lang="en-GB" dirty="0"/>
           </a:p>
         </p:txBody>
@@ -13151,9 +13258,10 @@
           <a:lstStyle/>
           <a:p>
             <a:r>
-              <a:rPr lang="en-GB"/>
+              <a:rPr lang="en-US"/>
               <a:t>11/03/2026</a:t>
             </a:r>
+            <a:endParaRPr lang="en-GB"/>
           </a:p>
         </p:txBody>
       </p:sp>
@@ -13178,6 +13286,10 @@
           <a:bodyPr/>
           <a:lstStyle/>
           <a:p>
+            <a:r>
+              <a:rPr lang="en-GB"/>
+              <a:t>Project LRC001 – Paul Kallarackel - 02029025</a:t>
+            </a:r>
             <a:endParaRPr lang="en-GB" dirty="0"/>
           </a:p>
         </p:txBody>
@@ -13510,9 +13622,10 @@
           <a:lstStyle/>
           <a:p>
             <a:r>
-              <a:rPr lang="en-GB"/>
+              <a:rPr lang="en-US"/>
               <a:t>11/03/2026</a:t>
             </a:r>
+            <a:endParaRPr lang="en-GB"/>
           </a:p>
         </p:txBody>
       </p:sp>
@@ -13537,6 +13650,10 @@
           <a:bodyPr/>
           <a:lstStyle/>
           <a:p>
+            <a:r>
+              <a:rPr lang="en-GB"/>
+              <a:t>Project LRC001 – Paul Kallarackel - 02029025</a:t>
+            </a:r>
             <a:endParaRPr lang="en-GB" dirty="0"/>
           </a:p>
         </p:txBody>
@@ -13979,9 +14096,10 @@
           <a:lstStyle/>
           <a:p>
             <a:r>
-              <a:rPr lang="en-GB"/>
+              <a:rPr lang="en-US"/>
               <a:t>11/03/2026</a:t>
             </a:r>
+            <a:endParaRPr lang="en-GB"/>
           </a:p>
         </p:txBody>
       </p:sp>
@@ -14006,6 +14124,10 @@
           <a:bodyPr/>
           <a:lstStyle/>
           <a:p>
+            <a:r>
+              <a:rPr lang="en-GB"/>
+              <a:t>Project LRC001 – Paul Kallarackel - 02029025</a:t>
+            </a:r>
             <a:endParaRPr lang="en-GB" dirty="0"/>
           </a:p>
         </p:txBody>
@@ -14448,9 +14570,10 @@
           <a:lstStyle/>
           <a:p>
             <a:r>
-              <a:rPr lang="en-GB"/>
+              <a:rPr lang="en-US"/>
               <a:t>11/03/2026</a:t>
             </a:r>
+            <a:endParaRPr lang="en-GB"/>
           </a:p>
         </p:txBody>
       </p:sp>
@@ -14475,6 +14598,10 @@
           <a:bodyPr/>
           <a:lstStyle/>
           <a:p>
+            <a:r>
+              <a:rPr lang="en-GB"/>
+              <a:t>Project LRC001 – Paul Kallarackel - 02029025</a:t>
+            </a:r>
             <a:endParaRPr lang="en-GB" dirty="0"/>
           </a:p>
         </p:txBody>
@@ -14909,9 +15036,10 @@
           <a:lstStyle/>
           <a:p>
             <a:r>
-              <a:rPr lang="en-GB"/>
+              <a:rPr lang="en-US"/>
               <a:t>11/03/2026</a:t>
             </a:r>
+            <a:endParaRPr lang="en-GB"/>
           </a:p>
         </p:txBody>
       </p:sp>
@@ -14936,6 +15064,10 @@
           <a:bodyPr/>
           <a:lstStyle/>
           <a:p>
+            <a:r>
+              <a:rPr lang="en-GB"/>
+              <a:t>Project LRC001 – Paul Kallarackel - 02029025</a:t>
+            </a:r>
             <a:endParaRPr lang="en-GB" dirty="0"/>
           </a:p>
         </p:txBody>
@@ -15567,9 +15699,10 @@
           <a:lstStyle/>
           <a:p>
             <a:r>
-              <a:rPr lang="en-GB"/>
+              <a:rPr lang="en-US"/>
               <a:t>11/03/2026</a:t>
             </a:r>
+            <a:endParaRPr lang="en-GB"/>
           </a:p>
         </p:txBody>
       </p:sp>
@@ -15594,6 +15727,10 @@
           <a:bodyPr/>
           <a:lstStyle/>
           <a:p>
+            <a:r>
+              <a:rPr lang="en-GB"/>
+              <a:t>Project LRC001 – Paul Kallarackel - 02029025</a:t>
+            </a:r>
             <a:endParaRPr lang="en-GB" dirty="0"/>
           </a:p>
         </p:txBody>
@@ -16225,9 +16362,10 @@
           <a:lstStyle/>
           <a:p>
             <a:r>
-              <a:rPr lang="en-GB"/>
+              <a:rPr lang="en-US"/>
               <a:t>11/03/2026</a:t>
             </a:r>
+            <a:endParaRPr lang="en-GB"/>
           </a:p>
         </p:txBody>
       </p:sp>
@@ -16252,6 +16390,10 @@
           <a:bodyPr/>
           <a:lstStyle/>
           <a:p>
+            <a:r>
+              <a:rPr lang="en-GB"/>
+              <a:t>Project LRC001 – Paul Kallarackel - 02029025</a:t>
+            </a:r>
             <a:endParaRPr lang="en-GB" dirty="0"/>
           </a:p>
         </p:txBody>
@@ -16875,9 +17017,10 @@
           <a:lstStyle/>
           <a:p>
             <a:r>
-              <a:rPr lang="en-GB"/>
+              <a:rPr lang="en-US"/>
               <a:t>11/03/2026</a:t>
             </a:r>
+            <a:endParaRPr lang="en-GB"/>
           </a:p>
         </p:txBody>
       </p:sp>
@@ -16902,6 +17045,10 @@
           <a:bodyPr/>
           <a:lstStyle/>
           <a:p>
+            <a:r>
+              <a:rPr lang="en-GB"/>
+              <a:t>Project LRC001 – Paul Kallarackel - 02029025</a:t>
+            </a:r>
             <a:endParaRPr lang="en-GB" dirty="0"/>
           </a:p>
         </p:txBody>
@@ -18882,9 +19029,10 @@
           <a:lstStyle/>
           <a:p>
             <a:r>
-              <a:rPr lang="en-GB"/>
+              <a:rPr lang="en-US"/>
               <a:t>11/03/2026</a:t>
             </a:r>
+            <a:endParaRPr lang="en-GB"/>
           </a:p>
         </p:txBody>
       </p:sp>
@@ -18909,6 +19057,10 @@
           <a:bodyPr/>
           <a:lstStyle/>
           <a:p>
+            <a:r>
+              <a:rPr lang="en-GB"/>
+              <a:t>Project LRC001 – Paul Kallarackel - 02029025</a:t>
+            </a:r>
             <a:endParaRPr lang="en-GB" dirty="0"/>
           </a:p>
         </p:txBody>
@@ -19205,9 +19357,10 @@
           <a:lstStyle/>
           <a:p>
             <a:r>
-              <a:rPr lang="en-GB"/>
+              <a:rPr lang="en-US"/>
               <a:t>11/03/2026</a:t>
             </a:r>
+            <a:endParaRPr lang="en-GB"/>
           </a:p>
         </p:txBody>
       </p:sp>
@@ -19232,6 +19385,10 @@
           <a:bodyPr/>
           <a:lstStyle/>
           <a:p>
+            <a:r>
+              <a:rPr lang="en-GB"/>
+              <a:t>Project LRC001 – Paul Kallarackel - 02029025</a:t>
+            </a:r>
             <a:endParaRPr lang="en-GB" dirty="0"/>
           </a:p>
         </p:txBody>
@@ -19520,9 +19677,10 @@
           <a:lstStyle/>
           <a:p>
             <a:r>
-              <a:rPr lang="en-GB"/>
+              <a:rPr lang="en-US"/>
               <a:t>11/03/2026</a:t>
             </a:r>
+            <a:endParaRPr lang="en-GB"/>
           </a:p>
         </p:txBody>
       </p:sp>
@@ -19547,6 +19705,10 @@
           <a:bodyPr/>
           <a:lstStyle/>
           <a:p>
+            <a:r>
+              <a:rPr lang="en-GB"/>
+              <a:t>Project LRC001 – Paul Kallarackel - 02029025</a:t>
+            </a:r>
             <a:endParaRPr lang="en-GB" dirty="0"/>
           </a:p>
         </p:txBody>
@@ -19843,9 +20005,10 @@
           <a:lstStyle/>
           <a:p>
             <a:r>
-              <a:rPr lang="en-GB"/>
+              <a:rPr lang="en-US"/>
               <a:t>11/03/2026</a:t>
             </a:r>
+            <a:endParaRPr lang="en-GB"/>
           </a:p>
         </p:txBody>
       </p:sp>
@@ -19870,6 +20033,10 @@
           <a:bodyPr/>
           <a:lstStyle/>
           <a:p>
+            <a:r>
+              <a:rPr lang="en-GB"/>
+              <a:t>Project LRC001 – Paul Kallarackel - 02029025</a:t>
+            </a:r>
             <a:endParaRPr lang="en-GB" dirty="0"/>
           </a:p>
         </p:txBody>
@@ -20166,9 +20333,10 @@
           <a:lstStyle/>
           <a:p>
             <a:r>
-              <a:rPr lang="en-GB"/>
+              <a:rPr lang="en-US"/>
               <a:t>11/03/2026</a:t>
             </a:r>
+            <a:endParaRPr lang="en-GB"/>
           </a:p>
         </p:txBody>
       </p:sp>
@@ -20193,6 +20361,10 @@
           <a:bodyPr/>
           <a:lstStyle/>
           <a:p>
+            <a:r>
+              <a:rPr lang="en-GB"/>
+              <a:t>Project LRC001 – Paul Kallarackel - 02029025</a:t>
+            </a:r>
             <a:endParaRPr lang="en-GB" dirty="0"/>
           </a:p>
         </p:txBody>
@@ -20481,9 +20653,10 @@
           <a:lstStyle/>
           <a:p>
             <a:r>
-              <a:rPr lang="en-GB"/>
+              <a:rPr lang="en-US"/>
               <a:t>11/03/2026</a:t>
             </a:r>
+            <a:endParaRPr lang="en-GB"/>
           </a:p>
         </p:txBody>
       </p:sp>
@@ -20508,6 +20681,10 @@
           <a:bodyPr/>
           <a:lstStyle/>
           <a:p>
+            <a:r>
+              <a:rPr lang="en-GB"/>
+              <a:t>Project LRC001 – Paul Kallarackel - 02029025</a:t>
+            </a:r>
             <a:endParaRPr lang="en-GB" dirty="0"/>
           </a:p>
         </p:txBody>
@@ -20713,9 +20890,10 @@
           <a:lstStyle/>
           <a:p>
             <a:r>
-              <a:rPr lang="en-GB"/>
+              <a:rPr lang="en-US"/>
               <a:t>11/03/2026</a:t>
             </a:r>
+            <a:endParaRPr lang="en-GB"/>
           </a:p>
         </p:txBody>
       </p:sp>
@@ -20740,6 +20918,10 @@
           <a:bodyPr/>
           <a:lstStyle/>
           <a:p>
+            <a:r>
+              <a:rPr lang="en-GB"/>
+              <a:t>Project LRC001 – Paul Kallarackel - 02029025</a:t>
+            </a:r>
             <a:endParaRPr lang="en-GB" dirty="0"/>
           </a:p>
         </p:txBody>
@@ -20945,9 +21127,10 @@
           <a:lstStyle/>
           <a:p>
             <a:r>
-              <a:rPr lang="en-GB"/>
+              <a:rPr lang="en-US"/>
               <a:t>11/03/2026</a:t>
             </a:r>
+            <a:endParaRPr lang="en-GB"/>
           </a:p>
         </p:txBody>
       </p:sp>
@@ -20972,6 +21155,10 @@
           <a:bodyPr/>
           <a:lstStyle/>
           <a:p>
+            <a:r>
+              <a:rPr lang="en-GB"/>
+              <a:t>Project LRC001 – Paul Kallarackel - 02029025</a:t>
+            </a:r>
             <a:endParaRPr lang="en-GB" dirty="0"/>
           </a:p>
         </p:txBody>
@@ -36742,9 +36929,10 @@
           <a:lstStyle/>
           <a:p>
             <a:r>
-              <a:rPr lang="en-GB"/>
+              <a:rPr lang="en-US"/>
               <a:t>11/03/2026</a:t>
             </a:r>
+            <a:endParaRPr lang="en-GB"/>
           </a:p>
         </p:txBody>
       </p:sp>
@@ -36769,7 +36957,10 @@
           <a:bodyPr/>
           <a:lstStyle/>
           <a:p>
-            <a:endParaRPr lang="en-GB"/>
+            <a:r>
+              <a:rPr lang="en-GB"/>
+              <a:t>Project LRC001 – Paul Kallarackel - 02029025</a:t>
+            </a:r>
           </a:p>
         </p:txBody>
       </p:sp>
@@ -36974,9 +37165,10 @@
           <a:lstStyle/>
           <a:p>
             <a:r>
-              <a:rPr lang="en-GB"/>
+              <a:rPr lang="en-US"/>
               <a:t>11/03/2026</a:t>
             </a:r>
+            <a:endParaRPr lang="en-GB"/>
           </a:p>
         </p:txBody>
       </p:sp>
@@ -37001,7 +37193,10 @@
           <a:bodyPr/>
           <a:lstStyle/>
           <a:p>
-            <a:endParaRPr lang="en-GB"/>
+            <a:r>
+              <a:rPr lang="en-GB"/>
+              <a:t>Project LRC001 – Paul Kallarackel - 02029025</a:t>
+            </a:r>
           </a:p>
         </p:txBody>
       </p:sp>
@@ -37207,9 +37402,10 @@
           <a:lstStyle/>
           <a:p>
             <a:r>
-              <a:rPr lang="en-GB"/>
+              <a:rPr lang="en-US"/>
               <a:t>11/03/2026</a:t>
             </a:r>
+            <a:endParaRPr lang="en-GB"/>
           </a:p>
         </p:txBody>
       </p:sp>
@@ -37234,6 +37430,10 @@
           <a:bodyPr/>
           <a:lstStyle/>
           <a:p>
+            <a:r>
+              <a:rPr lang="en-GB"/>
+              <a:t>Project LRC001 – Paul Kallarackel - 02029025</a:t>
+            </a:r>
             <a:endParaRPr lang="en-GB" dirty="0"/>
           </a:p>
         </p:txBody>
@@ -37459,9 +37659,10 @@
           <a:lstStyle/>
           <a:p>
             <a:r>
-              <a:rPr lang="en-GB"/>
+              <a:rPr lang="en-US"/>
               <a:t>11/03/2026</a:t>
             </a:r>
+            <a:endParaRPr lang="en-GB"/>
           </a:p>
         </p:txBody>
       </p:sp>
@@ -37486,7 +37687,10 @@
           <a:bodyPr/>
           <a:lstStyle/>
           <a:p>
-            <a:endParaRPr lang="en-GB"/>
+            <a:r>
+              <a:rPr lang="en-GB"/>
+              <a:t>Project LRC001 – Paul Kallarackel - 02029025</a:t>
+            </a:r>
           </a:p>
         </p:txBody>
       </p:sp>
@@ -37654,9 +37858,10 @@
           <a:lstStyle/>
           <a:p>
             <a:r>
-              <a:rPr lang="en-GB"/>
+              <a:rPr lang="en-US"/>
               <a:t>11/03/2026</a:t>
             </a:r>
+            <a:endParaRPr lang="en-GB"/>
           </a:p>
         </p:txBody>
       </p:sp>
@@ -37681,7 +37886,10 @@
           <a:bodyPr/>
           <a:lstStyle/>
           <a:p>
-            <a:endParaRPr lang="en-GB"/>
+            <a:r>
+              <a:rPr lang="en-GB"/>
+              <a:t>Project LRC001 – Paul Kallarackel - 02029025</a:t>
+            </a:r>
           </a:p>
         </p:txBody>
       </p:sp>
@@ -37777,9 +37985,10 @@
           <a:lstStyle/>
           <a:p>
             <a:r>
-              <a:rPr lang="en-GB"/>
+              <a:rPr lang="en-US"/>
               <a:t>11/03/2026</a:t>
             </a:r>
+            <a:endParaRPr lang="en-GB"/>
           </a:p>
         </p:txBody>
       </p:sp>
@@ -37804,7 +38013,10 @@
           <a:bodyPr/>
           <a:lstStyle/>
           <a:p>
-            <a:endParaRPr lang="en-GB"/>
+            <a:r>
+              <a:rPr lang="en-GB"/>
+              <a:t>Project LRC001 – Paul Kallarackel - 02029025</a:t>
+            </a:r>
           </a:p>
         </p:txBody>
       </p:sp>
@@ -37900,9 +38112,10 @@
           <a:lstStyle/>
           <a:p>
             <a:r>
-              <a:rPr lang="en-GB"/>
+              <a:rPr lang="en-US"/>
               <a:t>11/03/2026</a:t>
             </a:r>
+            <a:endParaRPr lang="en-GB"/>
           </a:p>
         </p:txBody>
       </p:sp>
@@ -37927,7 +38140,10 @@
           <a:bodyPr/>
           <a:lstStyle/>
           <a:p>
-            <a:endParaRPr lang="en-GB"/>
+            <a:r>
+              <a:rPr lang="en-GB"/>
+              <a:t>Project LRC001 – Paul Kallarackel - 02029025</a:t>
+            </a:r>
           </a:p>
         </p:txBody>
       </p:sp>
@@ -38061,9 +38277,10 @@
           <a:lstStyle/>
           <a:p>
             <a:r>
-              <a:rPr lang="en-GB"/>
+              <a:rPr lang="en-US"/>
               <a:t>11/03/2026</a:t>
             </a:r>
+            <a:endParaRPr lang="en-GB"/>
           </a:p>
         </p:txBody>
       </p:sp>
@@ -38088,6 +38305,10 @@
           <a:bodyPr/>
           <a:lstStyle/>
           <a:p>
+            <a:r>
+              <a:rPr lang="en-GB"/>
+              <a:t>Project LRC001 – Paul Kallarackel - 02029025</a:t>
+            </a:r>
             <a:endParaRPr lang="en-GB" dirty="0"/>
           </a:p>
         </p:txBody>
@@ -38322,9 +38543,10 @@
           <a:lstStyle/>
           <a:p>
             <a:r>
-              <a:rPr lang="en-GB"/>
+              <a:rPr lang="en-US"/>
               <a:t>11/03/2026</a:t>
             </a:r>
+            <a:endParaRPr lang="en-GB"/>
           </a:p>
         </p:txBody>
       </p:sp>
@@ -38349,6 +38571,10 @@
           <a:bodyPr/>
           <a:lstStyle/>
           <a:p>
+            <a:r>
+              <a:rPr lang="en-GB"/>
+              <a:t>Project LRC001 – Paul Kallarackel - 02029025</a:t>
+            </a:r>
             <a:endParaRPr lang="en-GB" dirty="0"/>
           </a:p>
         </p:txBody>
@@ -38595,9 +38821,10 @@
           </a:lstStyle>
           <a:p>
             <a:r>
-              <a:rPr lang="en-GB"/>
+              <a:rPr lang="en-US"/>
               <a:t>11/03/2026</a:t>
             </a:r>
+            <a:endParaRPr lang="en-GB"/>
           </a:p>
         </p:txBody>
       </p:sp>
@@ -38630,6 +38857,10 @@
             </a:lvl1pPr>
           </a:lstStyle>
           <a:p>
+            <a:r>
+              <a:rPr lang="en-GB"/>
+              <a:t>Project LRC001 – Paul Kallarackel - 02029025</a:t>
+            </a:r>
             <a:endParaRPr lang="en-GB" dirty="0"/>
           </a:p>
         </p:txBody>
@@ -39000,9 +39231,10 @@
           </a:lstStyle>
           <a:p>
             <a:r>
-              <a:rPr lang="en-GB"/>
+              <a:rPr lang="en-US"/>
               <a:t>11/03/2026</a:t>
             </a:r>
+            <a:endParaRPr lang="en-GB"/>
           </a:p>
         </p:txBody>
       </p:sp>
@@ -39045,6 +39277,10 @@
             </a:lvl1pPr>
           </a:lstStyle>
           <a:p>
+            <a:r>
+              <a:rPr lang="en-GB"/>
+              <a:t>Project LRC001 – Paul Kallarackel - 02029025</a:t>
+            </a:r>
             <a:endParaRPr lang="en-GB" dirty="0"/>
           </a:p>
         </p:txBody>
@@ -39093,7 +39329,7 @@
               <a:pPr/>
               <a:t>‹#›</a:t>
             </a:fld>
-            <a:endParaRPr lang="en-GB"/>
+            <a:endParaRPr lang="en-GB" dirty="0"/>
           </a:p>
         </p:txBody>
       </p:sp>
@@ -39807,9 +40043,10 @@
           <a:lstStyle/>
           <a:p>
             <a:r>
-              <a:rPr lang="en-GB"/>
+              <a:rPr lang="en-US"/>
               <a:t>11/03/2026</a:t>
             </a:r>
+            <a:endParaRPr lang="en-GB"/>
           </a:p>
         </p:txBody>
       </p:sp>
@@ -39834,6 +40071,10 @@
           <a:bodyPr/>
           <a:lstStyle/>
           <a:p>
+            <a:r>
+              <a:rPr lang="en-GB"/>
+              <a:t>Project LRC001 – Paul Kallarackel - 02029025</a:t>
+            </a:r>
             <a:endParaRPr lang="en-GB" dirty="0"/>
           </a:p>
         </p:txBody>
@@ -39987,9 +40228,10 @@
           <a:lstStyle/>
           <a:p>
             <a:r>
-              <a:rPr lang="en-GB"/>
+              <a:rPr lang="en-US"/>
               <a:t>11/03/2026</a:t>
             </a:r>
+            <a:endParaRPr lang="en-GB"/>
           </a:p>
         </p:txBody>
       </p:sp>
@@ -40014,6 +40256,10 @@
           <a:bodyPr/>
           <a:lstStyle/>
           <a:p>
+            <a:r>
+              <a:rPr lang="en-GB"/>
+              <a:t>Project LRC001 – Paul Kallarackel - 02029025</a:t>
+            </a:r>
             <a:endParaRPr lang="en-GB" dirty="0"/>
           </a:p>
         </p:txBody>
@@ -40193,9 +40439,10 @@
           <a:lstStyle/>
           <a:p>
             <a:r>
-              <a:rPr lang="en-GB"/>
+              <a:rPr lang="en-US"/>
               <a:t>11/03/2026</a:t>
             </a:r>
+            <a:endParaRPr lang="en-GB"/>
           </a:p>
         </p:txBody>
       </p:sp>
@@ -40220,6 +40467,10 @@
           <a:bodyPr/>
           <a:lstStyle/>
           <a:p>
+            <a:r>
+              <a:rPr lang="en-GB"/>
+              <a:t>Project LRC001 – Paul Kallarackel - 02029025</a:t>
+            </a:r>
             <a:endParaRPr lang="en-GB" dirty="0"/>
           </a:p>
         </p:txBody>
@@ -40724,9 +40975,10 @@
           <a:lstStyle/>
           <a:p>
             <a:r>
-              <a:rPr lang="en-GB"/>
+              <a:rPr lang="en-US"/>
               <a:t>11/03/2026</a:t>
             </a:r>
+            <a:endParaRPr lang="en-GB"/>
           </a:p>
         </p:txBody>
       </p:sp>
@@ -40751,6 +41003,10 @@
           <a:bodyPr/>
           <a:lstStyle/>
           <a:p>
+            <a:r>
+              <a:rPr lang="en-GB"/>
+              <a:t>Project LRC001 – Paul Kallarackel - 02029025</a:t>
+            </a:r>
             <a:endParaRPr lang="en-GB" dirty="0"/>
           </a:p>
         </p:txBody>
@@ -40930,9 +41186,10 @@
           <a:lstStyle/>
           <a:p>
             <a:r>
-              <a:rPr lang="en-GB"/>
+              <a:rPr lang="en-US"/>
               <a:t>11/03/2026</a:t>
             </a:r>
+            <a:endParaRPr lang="en-GB"/>
           </a:p>
         </p:txBody>
       </p:sp>
@@ -40957,6 +41214,10 @@
           <a:bodyPr/>
           <a:lstStyle/>
           <a:p>
+            <a:r>
+              <a:rPr lang="en-GB"/>
+              <a:t>Project LRC001 – Paul Kallarackel - 02029025</a:t>
+            </a:r>
             <a:endParaRPr lang="en-GB" dirty="0"/>
           </a:p>
         </p:txBody>
@@ -41859,9 +42120,10 @@
           <a:lstStyle/>
           <a:p>
             <a:r>
-              <a:rPr lang="en-GB"/>
+              <a:rPr lang="en-US"/>
               <a:t>11/03/2026</a:t>
             </a:r>
+            <a:endParaRPr lang="en-GB"/>
           </a:p>
         </p:txBody>
       </p:sp>
@@ -41886,6 +42148,10 @@
           <a:bodyPr/>
           <a:lstStyle/>
           <a:p>
+            <a:r>
+              <a:rPr lang="en-GB"/>
+              <a:t>Project LRC001 – Paul Kallarackel - 02029025</a:t>
+            </a:r>
             <a:endParaRPr lang="en-GB" dirty="0"/>
           </a:p>
         </p:txBody>
@@ -42065,9 +42331,10 @@
           <a:lstStyle/>
           <a:p>
             <a:r>
-              <a:rPr lang="en-GB"/>
+              <a:rPr lang="en-US"/>
               <a:t>11/03/2026</a:t>
             </a:r>
+            <a:endParaRPr lang="en-GB"/>
           </a:p>
         </p:txBody>
       </p:sp>
@@ -42092,6 +42359,10 @@
           <a:bodyPr/>
           <a:lstStyle/>
           <a:p>
+            <a:r>
+              <a:rPr lang="en-GB"/>
+              <a:t>Project LRC001 – Paul Kallarackel - 02029025</a:t>
+            </a:r>
             <a:endParaRPr lang="en-GB" dirty="0"/>
           </a:p>
         </p:txBody>
@@ -42525,7 +42796,7 @@
           <a:lstStyle/>
           <a:p>
             <a:r>
-              <a:rPr lang="en-GB"/>
+              <a:rPr lang="en-US"/>
               <a:t>11/03/2026</a:t>
             </a:r>
             <a:endParaRPr lang="en-GB" dirty="0"/>
@@ -42558,7 +42829,10 @@
           <a:bodyPr/>
           <a:lstStyle/>
           <a:p>
-            <a:endParaRPr lang="en-GB" dirty="0"/>
+            <a:r>
+              <a:rPr lang="en-GB" dirty="0"/>
+              <a:t>Project LRC001 – Paul Kallarackel - 02029025</a:t>
+            </a:r>
           </a:p>
         </p:txBody>
       </p:sp>
@@ -43027,9 +43301,10 @@
           <a:lstStyle/>
           <a:p>
             <a:r>
-              <a:rPr lang="en-GB"/>
+              <a:rPr lang="en-US"/>
               <a:t>11/03/2026</a:t>
             </a:r>
+            <a:endParaRPr lang="en-GB"/>
           </a:p>
         </p:txBody>
       </p:sp>
@@ -43054,6 +43329,10 @@
           <a:bodyPr/>
           <a:lstStyle/>
           <a:p>
+            <a:r>
+              <a:rPr lang="en-GB"/>
+              <a:t>Project LRC001 – Paul Kallarackel - 02029025</a:t>
+            </a:r>
             <a:endParaRPr lang="en-GB" dirty="0"/>
           </a:p>
         </p:txBody>
@@ -43459,9 +43738,10 @@
           <a:lstStyle/>
           <a:p>
             <a:r>
-              <a:rPr lang="en-GB"/>
+              <a:rPr lang="en-US"/>
               <a:t>11/03/2026</a:t>
             </a:r>
+            <a:endParaRPr lang="en-GB"/>
           </a:p>
         </p:txBody>
       </p:sp>
@@ -43486,6 +43766,10 @@
           <a:bodyPr/>
           <a:lstStyle/>
           <a:p>
+            <a:r>
+              <a:rPr lang="en-GB"/>
+              <a:t>Project LRC001 – Paul Kallarackel - 02029025</a:t>
+            </a:r>
             <a:endParaRPr lang="en-GB" dirty="0"/>
           </a:p>
         </p:txBody>
@@ -43609,9 +43893,10 @@
           <a:lstStyle/>
           <a:p>
             <a:r>
-              <a:rPr lang="en-GB"/>
+              <a:rPr lang="en-US"/>
               <a:t>11/03/2026</a:t>
             </a:r>
+            <a:endParaRPr lang="en-GB"/>
           </a:p>
         </p:txBody>
       </p:sp>
@@ -43636,6 +43921,10 @@
           <a:bodyPr/>
           <a:lstStyle/>
           <a:p>
+            <a:r>
+              <a:rPr lang="en-GB"/>
+              <a:t>Project LRC001 – Paul Kallarackel - 02029025</a:t>
+            </a:r>
             <a:endParaRPr lang="en-GB" dirty="0"/>
           </a:p>
         </p:txBody>
@@ -43921,9 +44210,10 @@
           <a:lstStyle/>
           <a:p>
             <a:r>
-              <a:rPr lang="en-GB"/>
+              <a:rPr lang="en-US"/>
               <a:t>11/03/2026</a:t>
             </a:r>
+            <a:endParaRPr lang="en-GB"/>
           </a:p>
         </p:txBody>
       </p:sp>
@@ -43948,6 +44238,10 @@
           <a:bodyPr/>
           <a:lstStyle/>
           <a:p>
+            <a:r>
+              <a:rPr lang="en-GB"/>
+              <a:t>Project LRC001 – Paul Kallarackel - 02029025</a:t>
+            </a:r>
             <a:endParaRPr lang="en-GB" dirty="0"/>
           </a:p>
         </p:txBody>
@@ -44131,9 +44425,10 @@
           <a:lstStyle/>
           <a:p>
             <a:r>
-              <a:rPr lang="en-GB"/>
+              <a:rPr lang="en-US"/>
               <a:t>11/03/2026</a:t>
             </a:r>
+            <a:endParaRPr lang="en-GB"/>
           </a:p>
         </p:txBody>
       </p:sp>
@@ -44158,6 +44453,10 @@
           <a:bodyPr/>
           <a:lstStyle/>
           <a:p>
+            <a:r>
+              <a:rPr lang="en-GB"/>
+              <a:t>Project LRC001 – Paul Kallarackel - 02029025</a:t>
+            </a:r>
             <a:endParaRPr lang="en-GB" dirty="0"/>
           </a:p>
         </p:txBody>
@@ -44491,9 +44790,10 @@
           <a:lstStyle/>
           <a:p>
             <a:r>
-              <a:rPr lang="en-GB"/>
+              <a:rPr lang="en-US"/>
               <a:t>11/03/2026</a:t>
             </a:r>
+            <a:endParaRPr lang="en-GB"/>
           </a:p>
         </p:txBody>
       </p:sp>
@@ -44518,6 +44818,10 @@
           <a:bodyPr/>
           <a:lstStyle/>
           <a:p>
+            <a:r>
+              <a:rPr lang="en-GB"/>
+              <a:t>Project LRC001 – Paul Kallarackel - 02029025</a:t>
+            </a:r>
             <a:endParaRPr lang="en-GB" dirty="0"/>
           </a:p>
         </p:txBody>
@@ -44730,9 +45034,10 @@
           <a:lstStyle/>
           <a:p>
             <a:r>
-              <a:rPr lang="en-GB"/>
+              <a:rPr lang="en-US"/>
               <a:t>11/03/2026</a:t>
             </a:r>
+            <a:endParaRPr lang="en-GB"/>
           </a:p>
         </p:txBody>
       </p:sp>
@@ -44757,6 +45062,10 @@
           <a:bodyPr/>
           <a:lstStyle/>
           <a:p>
+            <a:r>
+              <a:rPr lang="en-GB"/>
+              <a:t>Project LRC001 – Paul Kallarackel - 02029025</a:t>
+            </a:r>
             <a:endParaRPr lang="en-GB" dirty="0"/>
           </a:p>
         </p:txBody>
@@ -45594,18 +45903,18 @@
 </file>
 
 <file path=customXml/item1.xml><?xml version="1.0" encoding="utf-8"?>
+<p:properties xmlns:p="http://schemas.microsoft.com/office/2006/metadata/properties" xmlns:xsi="http://www.w3.org/2001/XMLSchema-instance" xmlns:pc="http://schemas.microsoft.com/office/infopath/2007/PartnerControls">
+  <documentManagement/>
+</p:properties>
+</file>
+
+<file path=customXml/item2.xml><?xml version="1.0" encoding="utf-8"?>
 <?mso-contentType ?>
 <FormTemplates xmlns="http://schemas.microsoft.com/sharepoint/v3/contenttype/forms">
   <Display>DocumentLibraryForm</Display>
   <Edit>DocumentLibraryForm</Edit>
   <New>DocumentLibraryForm</New>
 </FormTemplates>
-</file>
-
-<file path=customXml/item2.xml><?xml version="1.0" encoding="utf-8"?>
-<p:properties xmlns:p="http://schemas.microsoft.com/office/2006/metadata/properties" xmlns:xsi="http://www.w3.org/2001/XMLSchema-instance" xmlns:pc="http://schemas.microsoft.com/office/infopath/2007/PartnerControls">
-  <documentManagement/>
-</p:properties>
 </file>
 
 <file path=customXml/item3.xml><?xml version="1.0" encoding="utf-8"?>
@@ -45747,14 +46056,6 @@
 </file>
 
 <file path=customXml/itemProps1.xml><?xml version="1.0" encoding="utf-8"?>
-<ds:datastoreItem xmlns:ds="http://schemas.openxmlformats.org/officeDocument/2006/customXml" ds:itemID="{4B2545B1-F5A6-481C-9ECA-608EE6E0B992}">
-  <ds:schemaRefs>
-    <ds:schemaRef ds:uri="http://schemas.microsoft.com/sharepoint/v3/contenttype/forms"/>
-  </ds:schemaRefs>
-</ds:datastoreItem>
-</file>
-
-<file path=customXml/itemProps2.xml><?xml version="1.0" encoding="utf-8"?>
 <ds:datastoreItem xmlns:ds="http://schemas.openxmlformats.org/officeDocument/2006/customXml" ds:itemID="{82739277-F501-4DD3-AC3E-E62D288923D9}">
   <ds:schemaRefs>
     <ds:schemaRef ds:uri="http://schemas.microsoft.com/office/infopath/2007/PartnerControls"/>
@@ -45766,6 +46067,14 @@
     <ds:schemaRef ds:uri="http://schemas.openxmlformats.org/package/2006/metadata/core-properties"/>
     <ds:schemaRef ds:uri="58ccc919-a085-4c55-a8d0-fc57436857d8"/>
     <ds:schemaRef ds:uri="http://purl.org/dc/terms/"/>
+  </ds:schemaRefs>
+</ds:datastoreItem>
+</file>
+
+<file path=customXml/itemProps2.xml><?xml version="1.0" encoding="utf-8"?>
+<ds:datastoreItem xmlns:ds="http://schemas.openxmlformats.org/officeDocument/2006/customXml" ds:itemID="{4B2545B1-F5A6-481C-9ECA-608EE6E0B992}">
+  <ds:schemaRefs>
+    <ds:schemaRef ds:uri="http://schemas.microsoft.com/sharepoint/v3/contenttype/forms"/>
   </ds:schemaRefs>
 </ds:datastoreItem>
 </file>

</xml_diff>

<commit_message>
transitions to the ehaders with footer
</commit_message>
<xml_diff>
--- a/Interim.pptx
+++ b/Interim.pptx
@@ -8,7 +8,7 @@
     <p:notesMasterId r:id="rId27"/>
   </p:notesMasterIdLst>
   <p:sldIdLst>
-    <p:sldId id="258" r:id="rId5"/>
+    <p:sldId id="322" r:id="rId5"/>
     <p:sldId id="315" r:id="rId6"/>
     <p:sldId id="317" r:id="rId7"/>
     <p:sldId id="318" r:id="rId8"/>
@@ -129,6 +129,64 @@
     </a:lvl9pPr>
   </p:defaultTextStyle>
   <p:extLst>
+    <p:ext uri="{521415D9-36F7-43E2-AB2F-B90AF26B5E84}">
+      <p14:sectionLst xmlns:p14="http://schemas.microsoft.com/office/powerpoint/2010/main">
+        <p14:section name="Title" id="{509B564D-AF0A-4F12-840A-341F1EF9B068}">
+          <p14:sldIdLst>
+            <p14:sldId id="322"/>
+          </p14:sldIdLst>
+        </p14:section>
+        <p14:section name="Agenda" id="{4C605709-DED4-4BBA-B8BE-688FE0A0968D}">
+          <p14:sldIdLst>
+            <p14:sldId id="315"/>
+          </p14:sldIdLst>
+        </p14:section>
+        <p14:section name="Background" id="{ACFE30F6-51C3-4DFA-B2DE-9BCED4792339}">
+          <p14:sldIdLst>
+            <p14:sldId id="317"/>
+          </p14:sldIdLst>
+        </p14:section>
+        <p14:section name="Objectives" id="{2475FBC3-E0D1-405E-BE61-A33BD896B7FB}">
+          <p14:sldIdLst>
+            <p14:sldId id="318"/>
+          </p14:sldIdLst>
+        </p14:section>
+        <p14:section name="Progress" id="{3503A0BC-9183-4D70-9362-504D0EE41474}">
+          <p14:sldIdLst>
+            <p14:sldId id="319"/>
+          </p14:sldIdLst>
+        </p14:section>
+        <p14:section name="Plan" id="{6CD8984D-FFD5-44C4-B8CE-C9F3714B9E31}">
+          <p14:sldIdLst>
+            <p14:sldId id="321"/>
+          </p14:sldIdLst>
+        </p14:section>
+        <p14:section name="Summary" id="{F761EB85-FFD4-4172-8EB5-34F6C09B4BC1}">
+          <p14:sldIdLst>
+            <p14:sldId id="320"/>
+          </p14:sldIdLst>
+        </p14:section>
+        <p14:section name="Example" id="{731D3FBA-7084-433F-94DA-93455F149F64}">
+          <p14:sldIdLst>
+            <p14:sldId id="301"/>
+            <p14:sldId id="295"/>
+            <p14:sldId id="303"/>
+            <p14:sldId id="302"/>
+            <p14:sldId id="304"/>
+            <p14:sldId id="305"/>
+            <p14:sldId id="308"/>
+            <p14:sldId id="307"/>
+            <p14:sldId id="310"/>
+            <p14:sldId id="309"/>
+            <p14:sldId id="312"/>
+            <p14:sldId id="311"/>
+            <p14:sldId id="313"/>
+            <p14:sldId id="314"/>
+            <p14:sldId id="316"/>
+          </p14:sldIdLst>
+        </p14:section>
+      </p14:sectionLst>
+    </p:ext>
     <p:ext uri="{EFAFB233-063F-42B5-8137-9DF3F51BA10A}">
       <p15:sldGuideLst xmlns:p15="http://schemas.microsoft.com/office/powerpoint/2012/main">
         <p15:guide id="1" orient="horz" pos="2160" userDrawn="1">
@@ -2161,9 +2219,18 @@
   <p:clrMapOvr>
     <a:masterClrMapping/>
   </p:clrMapOvr>
-  <p:transition>
-    <p:fade/>
-  </p:transition>
+  <mc:AlternateContent xmlns:mc="http://schemas.openxmlformats.org/markup-compatibility/2006">
+    <mc:Choice xmlns:p159="http://schemas.microsoft.com/office/powerpoint/2015/09/main" Requires="p159">
+      <p:transition xmlns:p14="http://schemas.microsoft.com/office/powerpoint/2010/main" spd="slow" p14:dur="2000">
+        <p159:morph option="byObject"/>
+      </p:transition>
+    </mc:Choice>
+    <mc:Fallback>
+      <p:transition spd="slow">
+        <p:fade/>
+      </p:transition>
+    </mc:Fallback>
+  </mc:AlternateContent>
 </p:sldLayout>
 </file>
 
@@ -37524,6 +37591,67 @@
       </p:grpSpPr>
       <p:sp>
         <p:nvSpPr>
+          <p:cNvPr id="18" name="Rectangle: Rounded Corners 17">
+            <a:extLst>
+              <a:ext uri="{FF2B5EF4-FFF2-40B4-BE49-F238E27FC236}">
+                <a16:creationId xmlns:a16="http://schemas.microsoft.com/office/drawing/2014/main" id="{480E59A6-8341-9ABF-8536-7D9600F1854E}"/>
+              </a:ext>
+            </a:extLst>
+          </p:cNvPr>
+          <p:cNvSpPr/>
+          <p:nvPr userDrawn="1"/>
+        </p:nvSpPr>
+        <p:spPr>
+          <a:xfrm>
+            <a:off x="0" y="6405251"/>
+            <a:ext cx="12240000" cy="905497"/>
+          </a:xfrm>
+          <a:prstGeom prst="roundRect">
+            <a:avLst/>
+          </a:prstGeom>
+          <a:solidFill>
+            <a:schemeClr val="bg1">
+              <a:lumMod val="95000"/>
+            </a:schemeClr>
+          </a:solidFill>
+          <a:ln>
+            <a:solidFill>
+              <a:schemeClr val="accent1"/>
+            </a:solidFill>
+            <a:prstDash val="solid"/>
+          </a:ln>
+        </p:spPr>
+        <p:style>
+          <a:lnRef idx="2">
+            <a:schemeClr val="accent1">
+              <a:shade val="50000"/>
+            </a:schemeClr>
+          </a:lnRef>
+          <a:fillRef idx="1">
+            <a:schemeClr val="accent1"/>
+          </a:fillRef>
+          <a:effectRef idx="0">
+            <a:schemeClr val="accent1"/>
+          </a:effectRef>
+          <a:fontRef idx="minor">
+            <a:schemeClr val="lt1"/>
+          </a:fontRef>
+        </p:style>
+        <p:txBody>
+          <a:bodyPr rtlCol="0" anchor="ctr"/>
+          <a:lstStyle/>
+          <a:p>
+            <a:pPr algn="ctr"/>
+            <a:endParaRPr lang="en-GB" sz="1600" dirty="0">
+              <a:solidFill>
+                <a:schemeClr val="bg1"/>
+              </a:solidFill>
+            </a:endParaRPr>
+          </a:p>
+        </p:txBody>
+      </p:sp>
+      <p:sp>
+        <p:nvSpPr>
           <p:cNvPr id="2" name="Title 1">
             <a:extLst>
               <a:ext uri="{FF2B5EF4-FFF2-40B4-BE49-F238E27FC236}">
@@ -37675,7 +37803,12 @@
             <p:ph type="dt" sz="half" idx="14"/>
           </p:nvPr>
         </p:nvSpPr>
-        <p:spPr/>
+        <p:spPr>
+          <a:xfrm>
+            <a:off x="10665349" y="6537853"/>
+            <a:ext cx="1233647" cy="137270"/>
+          </a:xfrm>
+        </p:spPr>
         <p:txBody>
           <a:bodyPr/>
           <a:lstStyle/>
@@ -37704,16 +37837,20 @@
             <p:ph type="ftr" sz="quarter" idx="15"/>
           </p:nvPr>
         </p:nvSpPr>
-        <p:spPr/>
+        <p:spPr>
+          <a:xfrm>
+            <a:off x="1989261" y="6537853"/>
+            <a:ext cx="3423452" cy="137272"/>
+          </a:xfrm>
+        </p:spPr>
         <p:txBody>
           <a:bodyPr/>
           <a:lstStyle/>
           <a:p>
             <a:r>
-              <a:rPr lang="en-GB"/>
+              <a:rPr lang="en-GB" dirty="0"/>
               <a:t>Project LRC001 – Paul Kallarackel - 02029025</a:t>
             </a:r>
-            <a:endParaRPr lang="en-GB" dirty="0"/>
           </a:p>
         </p:txBody>
       </p:sp>
@@ -37733,7 +37870,12 @@
             <p:ph type="sldNum" sz="quarter" idx="16"/>
           </p:nvPr>
         </p:nvSpPr>
-        <p:spPr/>
+        <p:spPr>
+          <a:xfrm>
+            <a:off x="5960755" y="6537853"/>
+            <a:ext cx="318491" cy="137272"/>
+          </a:xfrm>
+        </p:spPr>
         <p:txBody>
           <a:bodyPr/>
           <a:lstStyle/>
@@ -37744,13 +37886,1445 @@
               <a:t>‹#›</a:t>
             </a:fld>
             <a:r>
-              <a:rPr lang="en-GB"/>
+              <a:rPr lang="en-GB" dirty="0"/>
               <a:t> / X </a:t>
             </a:r>
-            <a:endParaRPr lang="en-GB" dirty="0"/>
           </a:p>
         </p:txBody>
       </p:sp>
+      <p:grpSp>
+        <p:nvGrpSpPr>
+          <p:cNvPr id="21" name="Group 4">
+            <a:extLst>
+              <a:ext uri="{FF2B5EF4-FFF2-40B4-BE49-F238E27FC236}">
+                <a16:creationId xmlns:a16="http://schemas.microsoft.com/office/drawing/2014/main" id="{57CB34B6-325A-CE00-A3C4-38D33F3B4C48}"/>
+              </a:ext>
+            </a:extLst>
+          </p:cNvPr>
+          <p:cNvGrpSpPr>
+            <a:grpSpLocks noChangeAspect="1"/>
+          </p:cNvGrpSpPr>
+          <p:nvPr userDrawn="1"/>
+        </p:nvGrpSpPr>
+        <p:grpSpPr bwMode="auto">
+          <a:xfrm>
+            <a:off x="327025" y="6569208"/>
+            <a:ext cx="676041" cy="74559"/>
+            <a:chOff x="0" y="3473"/>
+            <a:chExt cx="15360" cy="1694"/>
+          </a:xfrm>
+          <a:solidFill>
+            <a:schemeClr val="accent1"/>
+          </a:solidFill>
+        </p:grpSpPr>
+        <p:sp>
+          <p:nvSpPr>
+            <p:cNvPr id="22" name="Freeform 5">
+              <a:extLst>
+                <a:ext uri="{FF2B5EF4-FFF2-40B4-BE49-F238E27FC236}">
+                  <a16:creationId xmlns:a16="http://schemas.microsoft.com/office/drawing/2014/main" id="{68673DCB-685F-0E20-2D58-FF81AC35BBD1}"/>
+                </a:ext>
+              </a:extLst>
+            </p:cNvPr>
+            <p:cNvSpPr>
+              <a:spLocks/>
+            </p:cNvSpPr>
+            <p:nvPr userDrawn="1"/>
+          </p:nvSpPr>
+          <p:spPr bwMode="auto">
+            <a:xfrm>
+              <a:off x="14261" y="3473"/>
+              <a:ext cx="1099" cy="1694"/>
+            </a:xfrm>
+            <a:custGeom>
+              <a:avLst/>
+              <a:gdLst>
+                <a:gd name="T0" fmla="*/ 0 w 1099"/>
+                <a:gd name="T1" fmla="*/ 0 h 1694"/>
+                <a:gd name="T2" fmla="*/ 0 w 1099"/>
+                <a:gd name="T3" fmla="*/ 1694 h 1694"/>
+                <a:gd name="T4" fmla="*/ 1099 w 1099"/>
+                <a:gd name="T5" fmla="*/ 1694 h 1694"/>
+                <a:gd name="T6" fmla="*/ 1099 w 1099"/>
+                <a:gd name="T7" fmla="*/ 1397 h 1694"/>
+                <a:gd name="T8" fmla="*/ 319 w 1099"/>
+                <a:gd name="T9" fmla="*/ 1397 h 1694"/>
+                <a:gd name="T10" fmla="*/ 319 w 1099"/>
+                <a:gd name="T11" fmla="*/ 0 h 1694"/>
+                <a:gd name="T12" fmla="*/ 0 w 1099"/>
+                <a:gd name="T13" fmla="*/ 0 h 1694"/>
+              </a:gdLst>
+              <a:ahLst/>
+              <a:cxnLst>
+                <a:cxn ang="0">
+                  <a:pos x="T0" y="T1"/>
+                </a:cxn>
+                <a:cxn ang="0">
+                  <a:pos x="T2" y="T3"/>
+                </a:cxn>
+                <a:cxn ang="0">
+                  <a:pos x="T4" y="T5"/>
+                </a:cxn>
+                <a:cxn ang="0">
+                  <a:pos x="T6" y="T7"/>
+                </a:cxn>
+                <a:cxn ang="0">
+                  <a:pos x="T8" y="T9"/>
+                </a:cxn>
+                <a:cxn ang="0">
+                  <a:pos x="T10" y="T11"/>
+                </a:cxn>
+                <a:cxn ang="0">
+                  <a:pos x="T12" y="T13"/>
+                </a:cxn>
+              </a:cxnLst>
+              <a:rect l="0" t="0" r="r" b="b"/>
+              <a:pathLst>
+                <a:path w="1099" h="1694">
+                  <a:moveTo>
+                    <a:pt x="0" y="0"/>
+                  </a:moveTo>
+                  <a:lnTo>
+                    <a:pt x="0" y="1694"/>
+                  </a:lnTo>
+                  <a:lnTo>
+                    <a:pt x="1099" y="1694"/>
+                  </a:lnTo>
+                  <a:lnTo>
+                    <a:pt x="1099" y="1397"/>
+                  </a:lnTo>
+                  <a:lnTo>
+                    <a:pt x="319" y="1397"/>
+                  </a:lnTo>
+                  <a:lnTo>
+                    <a:pt x="319" y="0"/>
+                  </a:lnTo>
+                  <a:lnTo>
+                    <a:pt x="0" y="0"/>
+                  </a:lnTo>
+                  <a:close/>
+                </a:path>
+              </a:pathLst>
+            </a:custGeom>
+            <a:grpFill/>
+            <a:ln>
+              <a:noFill/>
+            </a:ln>
+            <a:extLst>
+              <a:ext uri="{91240B29-F687-4F45-9708-019B960494DF}">
+                <a14:hiddenLine xmlns:a14="http://schemas.microsoft.com/office/drawing/2010/main" w="9525">
+                  <a:solidFill>
+                    <a:srgbClr val="000000"/>
+                  </a:solidFill>
+                  <a:round/>
+                  <a:headEnd/>
+                  <a:tailEnd/>
+                </a14:hiddenLine>
+              </a:ext>
+            </a:extLst>
+          </p:spPr>
+          <p:txBody>
+            <a:bodyPr vert="horz" wrap="square" lIns="91440" tIns="45720" rIns="91440" bIns="45720" numCol="1" anchor="t" anchorCtr="0" compatLnSpc="1">
+              <a:prstTxWarp prst="textNoShape">
+                <a:avLst/>
+              </a:prstTxWarp>
+            </a:bodyPr>
+            <a:lstStyle/>
+            <a:p>
+              <a:endParaRPr lang="en-US" sz="900"/>
+            </a:p>
+          </p:txBody>
+        </p:sp>
+        <p:sp>
+          <p:nvSpPr>
+            <p:cNvPr id="23" name="Freeform 6">
+              <a:extLst>
+                <a:ext uri="{FF2B5EF4-FFF2-40B4-BE49-F238E27FC236}">
+                  <a16:creationId xmlns:a16="http://schemas.microsoft.com/office/drawing/2014/main" id="{11051E77-3054-CA07-0832-C66CE9CB14ED}"/>
+                </a:ext>
+              </a:extLst>
+            </p:cNvPr>
+            <p:cNvSpPr>
+              <a:spLocks noEditPoints="1"/>
+            </p:cNvSpPr>
+            <p:nvPr userDrawn="1"/>
+          </p:nvSpPr>
+          <p:spPr bwMode="auto">
+            <a:xfrm>
+              <a:off x="12002" y="3473"/>
+              <a:ext cx="1535" cy="1694"/>
+            </a:xfrm>
+            <a:custGeom>
+              <a:avLst/>
+              <a:gdLst>
+                <a:gd name="T0" fmla="*/ 556 w 1535"/>
+                <a:gd name="T1" fmla="*/ 0 h 1694"/>
+                <a:gd name="T2" fmla="*/ 0 w 1535"/>
+                <a:gd name="T3" fmla="*/ 1694 h 1694"/>
+                <a:gd name="T4" fmla="*/ 337 w 1535"/>
+                <a:gd name="T5" fmla="*/ 1694 h 1694"/>
+                <a:gd name="T6" fmla="*/ 453 w 1535"/>
+                <a:gd name="T7" fmla="*/ 1321 h 1694"/>
+                <a:gd name="T8" fmla="*/ 1083 w 1535"/>
+                <a:gd name="T9" fmla="*/ 1321 h 1694"/>
+                <a:gd name="T10" fmla="*/ 1197 w 1535"/>
+                <a:gd name="T11" fmla="*/ 1694 h 1694"/>
+                <a:gd name="T12" fmla="*/ 1535 w 1535"/>
+                <a:gd name="T13" fmla="*/ 1694 h 1694"/>
+                <a:gd name="T14" fmla="*/ 978 w 1535"/>
+                <a:gd name="T15" fmla="*/ 0 h 1694"/>
+                <a:gd name="T16" fmla="*/ 556 w 1535"/>
+                <a:gd name="T17" fmla="*/ 0 h 1694"/>
+                <a:gd name="T18" fmla="*/ 768 w 1535"/>
+                <a:gd name="T19" fmla="*/ 301 h 1694"/>
+                <a:gd name="T20" fmla="*/ 998 w 1535"/>
+                <a:gd name="T21" fmla="*/ 1048 h 1694"/>
+                <a:gd name="T22" fmla="*/ 536 w 1535"/>
+                <a:gd name="T23" fmla="*/ 1048 h 1694"/>
+                <a:gd name="T24" fmla="*/ 768 w 1535"/>
+                <a:gd name="T25" fmla="*/ 301 h 1694"/>
+              </a:gdLst>
+              <a:ahLst/>
+              <a:cxnLst>
+                <a:cxn ang="0">
+                  <a:pos x="T0" y="T1"/>
+                </a:cxn>
+                <a:cxn ang="0">
+                  <a:pos x="T2" y="T3"/>
+                </a:cxn>
+                <a:cxn ang="0">
+                  <a:pos x="T4" y="T5"/>
+                </a:cxn>
+                <a:cxn ang="0">
+                  <a:pos x="T6" y="T7"/>
+                </a:cxn>
+                <a:cxn ang="0">
+                  <a:pos x="T8" y="T9"/>
+                </a:cxn>
+                <a:cxn ang="0">
+                  <a:pos x="T10" y="T11"/>
+                </a:cxn>
+                <a:cxn ang="0">
+                  <a:pos x="T12" y="T13"/>
+                </a:cxn>
+                <a:cxn ang="0">
+                  <a:pos x="T14" y="T15"/>
+                </a:cxn>
+                <a:cxn ang="0">
+                  <a:pos x="T16" y="T17"/>
+                </a:cxn>
+                <a:cxn ang="0">
+                  <a:pos x="T18" y="T19"/>
+                </a:cxn>
+                <a:cxn ang="0">
+                  <a:pos x="T20" y="T21"/>
+                </a:cxn>
+                <a:cxn ang="0">
+                  <a:pos x="T22" y="T23"/>
+                </a:cxn>
+                <a:cxn ang="0">
+                  <a:pos x="T24" y="T25"/>
+                </a:cxn>
+              </a:cxnLst>
+              <a:rect l="0" t="0" r="r" b="b"/>
+              <a:pathLst>
+                <a:path w="1535" h="1694">
+                  <a:moveTo>
+                    <a:pt x="556" y="0"/>
+                  </a:moveTo>
+                  <a:lnTo>
+                    <a:pt x="0" y="1694"/>
+                  </a:lnTo>
+                  <a:lnTo>
+                    <a:pt x="337" y="1694"/>
+                  </a:lnTo>
+                  <a:lnTo>
+                    <a:pt x="453" y="1321"/>
+                  </a:lnTo>
+                  <a:lnTo>
+                    <a:pt x="1083" y="1321"/>
+                  </a:lnTo>
+                  <a:lnTo>
+                    <a:pt x="1197" y="1694"/>
+                  </a:lnTo>
+                  <a:lnTo>
+                    <a:pt x="1535" y="1694"/>
+                  </a:lnTo>
+                  <a:lnTo>
+                    <a:pt x="978" y="0"/>
+                  </a:lnTo>
+                  <a:lnTo>
+                    <a:pt x="556" y="0"/>
+                  </a:lnTo>
+                  <a:close/>
+                  <a:moveTo>
+                    <a:pt x="768" y="301"/>
+                  </a:moveTo>
+                  <a:lnTo>
+                    <a:pt x="998" y="1048"/>
+                  </a:lnTo>
+                  <a:lnTo>
+                    <a:pt x="536" y="1048"/>
+                  </a:lnTo>
+                  <a:lnTo>
+                    <a:pt x="768" y="301"/>
+                  </a:lnTo>
+                  <a:close/>
+                </a:path>
+              </a:pathLst>
+            </a:custGeom>
+            <a:grpFill/>
+            <a:ln>
+              <a:noFill/>
+            </a:ln>
+            <a:extLst>
+              <a:ext uri="{91240B29-F687-4F45-9708-019B960494DF}">
+                <a14:hiddenLine xmlns:a14="http://schemas.microsoft.com/office/drawing/2010/main" w="9525">
+                  <a:solidFill>
+                    <a:srgbClr val="000000"/>
+                  </a:solidFill>
+                  <a:round/>
+                  <a:headEnd/>
+                  <a:tailEnd/>
+                </a14:hiddenLine>
+              </a:ext>
+            </a:extLst>
+          </p:spPr>
+          <p:txBody>
+            <a:bodyPr vert="horz" wrap="square" lIns="91440" tIns="45720" rIns="91440" bIns="45720" numCol="1" anchor="t" anchorCtr="0" compatLnSpc="1">
+              <a:prstTxWarp prst="textNoShape">
+                <a:avLst/>
+              </a:prstTxWarp>
+            </a:bodyPr>
+            <a:lstStyle/>
+            <a:p>
+              <a:endParaRPr lang="en-US" sz="900"/>
+            </a:p>
+          </p:txBody>
+        </p:sp>
+        <p:sp>
+          <p:nvSpPr>
+            <p:cNvPr id="24" name="Freeform 7">
+              <a:extLst>
+                <a:ext uri="{FF2B5EF4-FFF2-40B4-BE49-F238E27FC236}">
+                  <a16:creationId xmlns:a16="http://schemas.microsoft.com/office/drawing/2014/main" id="{EEB86B3A-7C72-FDE1-B172-E799191E0F78}"/>
+                </a:ext>
+              </a:extLst>
+            </p:cNvPr>
+            <p:cNvSpPr>
+              <a:spLocks/>
+            </p:cNvSpPr>
+            <p:nvPr userDrawn="1"/>
+          </p:nvSpPr>
+          <p:spPr bwMode="auto">
+            <a:xfrm>
+              <a:off x="10250" y="3473"/>
+              <a:ext cx="1113" cy="1694"/>
+            </a:xfrm>
+            <a:custGeom>
+              <a:avLst/>
+              <a:gdLst>
+                <a:gd name="T0" fmla="*/ 0 w 1113"/>
+                <a:gd name="T1" fmla="*/ 0 h 1694"/>
+                <a:gd name="T2" fmla="*/ 0 w 1113"/>
+                <a:gd name="T3" fmla="*/ 297 h 1694"/>
+                <a:gd name="T4" fmla="*/ 396 w 1113"/>
+                <a:gd name="T5" fmla="*/ 297 h 1694"/>
+                <a:gd name="T6" fmla="*/ 396 w 1113"/>
+                <a:gd name="T7" fmla="*/ 1397 h 1694"/>
+                <a:gd name="T8" fmla="*/ 0 w 1113"/>
+                <a:gd name="T9" fmla="*/ 1397 h 1694"/>
+                <a:gd name="T10" fmla="*/ 0 w 1113"/>
+                <a:gd name="T11" fmla="*/ 1694 h 1694"/>
+                <a:gd name="T12" fmla="*/ 1113 w 1113"/>
+                <a:gd name="T13" fmla="*/ 1694 h 1694"/>
+                <a:gd name="T14" fmla="*/ 1113 w 1113"/>
+                <a:gd name="T15" fmla="*/ 1397 h 1694"/>
+                <a:gd name="T16" fmla="*/ 716 w 1113"/>
+                <a:gd name="T17" fmla="*/ 1397 h 1694"/>
+                <a:gd name="T18" fmla="*/ 716 w 1113"/>
+                <a:gd name="T19" fmla="*/ 297 h 1694"/>
+                <a:gd name="T20" fmla="*/ 1113 w 1113"/>
+                <a:gd name="T21" fmla="*/ 297 h 1694"/>
+                <a:gd name="T22" fmla="*/ 1113 w 1113"/>
+                <a:gd name="T23" fmla="*/ 0 h 1694"/>
+                <a:gd name="T24" fmla="*/ 0 w 1113"/>
+                <a:gd name="T25" fmla="*/ 0 h 1694"/>
+              </a:gdLst>
+              <a:ahLst/>
+              <a:cxnLst>
+                <a:cxn ang="0">
+                  <a:pos x="T0" y="T1"/>
+                </a:cxn>
+                <a:cxn ang="0">
+                  <a:pos x="T2" y="T3"/>
+                </a:cxn>
+                <a:cxn ang="0">
+                  <a:pos x="T4" y="T5"/>
+                </a:cxn>
+                <a:cxn ang="0">
+                  <a:pos x="T6" y="T7"/>
+                </a:cxn>
+                <a:cxn ang="0">
+                  <a:pos x="T8" y="T9"/>
+                </a:cxn>
+                <a:cxn ang="0">
+                  <a:pos x="T10" y="T11"/>
+                </a:cxn>
+                <a:cxn ang="0">
+                  <a:pos x="T12" y="T13"/>
+                </a:cxn>
+                <a:cxn ang="0">
+                  <a:pos x="T14" y="T15"/>
+                </a:cxn>
+                <a:cxn ang="0">
+                  <a:pos x="T16" y="T17"/>
+                </a:cxn>
+                <a:cxn ang="0">
+                  <a:pos x="T18" y="T19"/>
+                </a:cxn>
+                <a:cxn ang="0">
+                  <a:pos x="T20" y="T21"/>
+                </a:cxn>
+                <a:cxn ang="0">
+                  <a:pos x="T22" y="T23"/>
+                </a:cxn>
+                <a:cxn ang="0">
+                  <a:pos x="T24" y="T25"/>
+                </a:cxn>
+              </a:cxnLst>
+              <a:rect l="0" t="0" r="r" b="b"/>
+              <a:pathLst>
+                <a:path w="1113" h="1694">
+                  <a:moveTo>
+                    <a:pt x="0" y="0"/>
+                  </a:moveTo>
+                  <a:lnTo>
+                    <a:pt x="0" y="297"/>
+                  </a:lnTo>
+                  <a:lnTo>
+                    <a:pt x="396" y="297"/>
+                  </a:lnTo>
+                  <a:lnTo>
+                    <a:pt x="396" y="1397"/>
+                  </a:lnTo>
+                  <a:lnTo>
+                    <a:pt x="0" y="1397"/>
+                  </a:lnTo>
+                  <a:lnTo>
+                    <a:pt x="0" y="1694"/>
+                  </a:lnTo>
+                  <a:lnTo>
+                    <a:pt x="1113" y="1694"/>
+                  </a:lnTo>
+                  <a:lnTo>
+                    <a:pt x="1113" y="1397"/>
+                  </a:lnTo>
+                  <a:lnTo>
+                    <a:pt x="716" y="1397"/>
+                  </a:lnTo>
+                  <a:lnTo>
+                    <a:pt x="716" y="297"/>
+                  </a:lnTo>
+                  <a:lnTo>
+                    <a:pt x="1113" y="297"/>
+                  </a:lnTo>
+                  <a:lnTo>
+                    <a:pt x="1113" y="0"/>
+                  </a:lnTo>
+                  <a:lnTo>
+                    <a:pt x="0" y="0"/>
+                  </a:lnTo>
+                  <a:close/>
+                </a:path>
+              </a:pathLst>
+            </a:custGeom>
+            <a:grpFill/>
+            <a:ln>
+              <a:noFill/>
+            </a:ln>
+            <a:extLst>
+              <a:ext uri="{91240B29-F687-4F45-9708-019B960494DF}">
+                <a14:hiddenLine xmlns:a14="http://schemas.microsoft.com/office/drawing/2010/main" w="9525">
+                  <a:solidFill>
+                    <a:srgbClr val="000000"/>
+                  </a:solidFill>
+                  <a:round/>
+                  <a:headEnd/>
+                  <a:tailEnd/>
+                </a14:hiddenLine>
+              </a:ext>
+            </a:extLst>
+          </p:spPr>
+          <p:txBody>
+            <a:bodyPr vert="horz" wrap="square" lIns="91440" tIns="45720" rIns="91440" bIns="45720" numCol="1" anchor="t" anchorCtr="0" compatLnSpc="1">
+              <a:prstTxWarp prst="textNoShape">
+                <a:avLst/>
+              </a:prstTxWarp>
+            </a:bodyPr>
+            <a:lstStyle/>
+            <a:p>
+              <a:endParaRPr lang="en-US" sz="900"/>
+            </a:p>
+          </p:txBody>
+        </p:sp>
+        <p:sp>
+          <p:nvSpPr>
+            <p:cNvPr id="25" name="Freeform 8">
+              <a:extLst>
+                <a:ext uri="{FF2B5EF4-FFF2-40B4-BE49-F238E27FC236}">
+                  <a16:creationId xmlns:a16="http://schemas.microsoft.com/office/drawing/2014/main" id="{4BA8CD0D-D8CD-F176-0CF0-ED9B31AD4090}"/>
+                </a:ext>
+              </a:extLst>
+            </p:cNvPr>
+            <p:cNvSpPr>
+              <a:spLocks noEditPoints="1"/>
+            </p:cNvSpPr>
+            <p:nvPr userDrawn="1"/>
+          </p:nvSpPr>
+          <p:spPr bwMode="auto">
+            <a:xfrm>
+              <a:off x="8263" y="3473"/>
+              <a:ext cx="1317" cy="1694"/>
+            </a:xfrm>
+            <a:custGeom>
+              <a:avLst/>
+              <a:gdLst>
+                <a:gd name="T0" fmla="*/ 884 w 932"/>
+                <a:gd name="T1" fmla="*/ 372 h 1199"/>
+                <a:gd name="T2" fmla="*/ 442 w 932"/>
+                <a:gd name="T3" fmla="*/ 0 h 1199"/>
+                <a:gd name="T4" fmla="*/ 0 w 932"/>
+                <a:gd name="T5" fmla="*/ 0 h 1199"/>
+                <a:gd name="T6" fmla="*/ 0 w 932"/>
+                <a:gd name="T7" fmla="*/ 1199 h 1199"/>
+                <a:gd name="T8" fmla="*/ 227 w 932"/>
+                <a:gd name="T9" fmla="*/ 1199 h 1199"/>
+                <a:gd name="T10" fmla="*/ 227 w 932"/>
+                <a:gd name="T11" fmla="*/ 755 h 1199"/>
+                <a:gd name="T12" fmla="*/ 418 w 932"/>
+                <a:gd name="T13" fmla="*/ 755 h 1199"/>
+                <a:gd name="T14" fmla="*/ 450 w 932"/>
+                <a:gd name="T15" fmla="*/ 755 h 1199"/>
+                <a:gd name="T16" fmla="*/ 681 w 932"/>
+                <a:gd name="T17" fmla="*/ 1199 h 1199"/>
+                <a:gd name="T18" fmla="*/ 932 w 932"/>
+                <a:gd name="T19" fmla="*/ 1199 h 1199"/>
+                <a:gd name="T20" fmla="*/ 676 w 932"/>
+                <a:gd name="T21" fmla="*/ 707 h 1199"/>
+                <a:gd name="T22" fmla="*/ 884 w 932"/>
+                <a:gd name="T23" fmla="*/ 372 h 1199"/>
+                <a:gd name="T24" fmla="*/ 645 w 932"/>
+                <a:gd name="T25" fmla="*/ 372 h 1199"/>
+                <a:gd name="T26" fmla="*/ 418 w 932"/>
+                <a:gd name="T27" fmla="*/ 562 h 1199"/>
+                <a:gd name="T28" fmla="*/ 227 w 932"/>
+                <a:gd name="T29" fmla="*/ 562 h 1199"/>
+                <a:gd name="T30" fmla="*/ 227 w 932"/>
+                <a:gd name="T31" fmla="*/ 194 h 1199"/>
+                <a:gd name="T32" fmla="*/ 418 w 932"/>
+                <a:gd name="T33" fmla="*/ 194 h 1199"/>
+                <a:gd name="T34" fmla="*/ 645 w 932"/>
+                <a:gd name="T35" fmla="*/ 372 h 1199"/>
+              </a:gdLst>
+              <a:ahLst/>
+              <a:cxnLst>
+                <a:cxn ang="0">
+                  <a:pos x="T0" y="T1"/>
+                </a:cxn>
+                <a:cxn ang="0">
+                  <a:pos x="T2" y="T3"/>
+                </a:cxn>
+                <a:cxn ang="0">
+                  <a:pos x="T4" y="T5"/>
+                </a:cxn>
+                <a:cxn ang="0">
+                  <a:pos x="T6" y="T7"/>
+                </a:cxn>
+                <a:cxn ang="0">
+                  <a:pos x="T8" y="T9"/>
+                </a:cxn>
+                <a:cxn ang="0">
+                  <a:pos x="T10" y="T11"/>
+                </a:cxn>
+                <a:cxn ang="0">
+                  <a:pos x="T12" y="T13"/>
+                </a:cxn>
+                <a:cxn ang="0">
+                  <a:pos x="T14" y="T15"/>
+                </a:cxn>
+                <a:cxn ang="0">
+                  <a:pos x="T16" y="T17"/>
+                </a:cxn>
+                <a:cxn ang="0">
+                  <a:pos x="T18" y="T19"/>
+                </a:cxn>
+                <a:cxn ang="0">
+                  <a:pos x="T20" y="T21"/>
+                </a:cxn>
+                <a:cxn ang="0">
+                  <a:pos x="T22" y="T23"/>
+                </a:cxn>
+                <a:cxn ang="0">
+                  <a:pos x="T24" y="T25"/>
+                </a:cxn>
+                <a:cxn ang="0">
+                  <a:pos x="T26" y="T27"/>
+                </a:cxn>
+                <a:cxn ang="0">
+                  <a:pos x="T28" y="T29"/>
+                </a:cxn>
+                <a:cxn ang="0">
+                  <a:pos x="T30" y="T31"/>
+                </a:cxn>
+                <a:cxn ang="0">
+                  <a:pos x="T32" y="T33"/>
+                </a:cxn>
+                <a:cxn ang="0">
+                  <a:pos x="T34" y="T35"/>
+                </a:cxn>
+              </a:cxnLst>
+              <a:rect l="0" t="0" r="r" b="b"/>
+              <a:pathLst>
+                <a:path w="932" h="1199">
+                  <a:moveTo>
+                    <a:pt x="884" y="372"/>
+                  </a:moveTo>
+                  <a:cubicBezTo>
+                    <a:pt x="884" y="92"/>
+                    <a:pt x="693" y="0"/>
+                    <a:pt x="442" y="0"/>
+                  </a:cubicBezTo>
+                  <a:cubicBezTo>
+                    <a:pt x="0" y="0"/>
+                    <a:pt x="0" y="0"/>
+                    <a:pt x="0" y="0"/>
+                  </a:cubicBezTo>
+                  <a:cubicBezTo>
+                    <a:pt x="0" y="1199"/>
+                    <a:pt x="0" y="1199"/>
+                    <a:pt x="0" y="1199"/>
+                  </a:cubicBezTo>
+                  <a:cubicBezTo>
+                    <a:pt x="227" y="1199"/>
+                    <a:pt x="227" y="1199"/>
+                    <a:pt x="227" y="1199"/>
+                  </a:cubicBezTo>
+                  <a:cubicBezTo>
+                    <a:pt x="227" y="755"/>
+                    <a:pt x="227" y="755"/>
+                    <a:pt x="227" y="755"/>
+                  </a:cubicBezTo>
+                  <a:cubicBezTo>
+                    <a:pt x="418" y="755"/>
+                    <a:pt x="418" y="755"/>
+                    <a:pt x="418" y="755"/>
+                  </a:cubicBezTo>
+                  <a:cubicBezTo>
+                    <a:pt x="429" y="755"/>
+                    <a:pt x="439" y="755"/>
+                    <a:pt x="450" y="755"/>
+                  </a:cubicBezTo>
+                  <a:cubicBezTo>
+                    <a:pt x="681" y="1199"/>
+                    <a:pt x="681" y="1199"/>
+                    <a:pt x="681" y="1199"/>
+                  </a:cubicBezTo>
+                  <a:cubicBezTo>
+                    <a:pt x="932" y="1199"/>
+                    <a:pt x="932" y="1199"/>
+                    <a:pt x="932" y="1199"/>
+                  </a:cubicBezTo>
+                  <a:cubicBezTo>
+                    <a:pt x="676" y="707"/>
+                    <a:pt x="676" y="707"/>
+                    <a:pt x="676" y="707"/>
+                  </a:cubicBezTo>
+                  <a:cubicBezTo>
+                    <a:pt x="801" y="652"/>
+                    <a:pt x="884" y="545"/>
+                    <a:pt x="884" y="372"/>
+                  </a:cubicBezTo>
+                  <a:moveTo>
+                    <a:pt x="645" y="372"/>
+                  </a:moveTo>
+                  <a:cubicBezTo>
+                    <a:pt x="645" y="516"/>
+                    <a:pt x="562" y="562"/>
+                    <a:pt x="418" y="562"/>
+                  </a:cubicBezTo>
+                  <a:cubicBezTo>
+                    <a:pt x="227" y="562"/>
+                    <a:pt x="227" y="562"/>
+                    <a:pt x="227" y="562"/>
+                  </a:cubicBezTo>
+                  <a:cubicBezTo>
+                    <a:pt x="227" y="194"/>
+                    <a:pt x="227" y="194"/>
+                    <a:pt x="227" y="194"/>
+                  </a:cubicBezTo>
+                  <a:cubicBezTo>
+                    <a:pt x="418" y="194"/>
+                    <a:pt x="418" y="194"/>
+                    <a:pt x="418" y="194"/>
+                  </a:cubicBezTo>
+                  <a:cubicBezTo>
+                    <a:pt x="574" y="194"/>
+                    <a:pt x="645" y="252"/>
+                    <a:pt x="645" y="372"/>
+                  </a:cubicBezTo>
+                </a:path>
+              </a:pathLst>
+            </a:custGeom>
+            <a:grpFill/>
+            <a:ln>
+              <a:noFill/>
+            </a:ln>
+            <a:extLst>
+              <a:ext uri="{91240B29-F687-4F45-9708-019B960494DF}">
+                <a14:hiddenLine xmlns:a14="http://schemas.microsoft.com/office/drawing/2010/main" w="9525">
+                  <a:solidFill>
+                    <a:srgbClr val="000000"/>
+                  </a:solidFill>
+                  <a:round/>
+                  <a:headEnd/>
+                  <a:tailEnd/>
+                </a14:hiddenLine>
+              </a:ext>
+            </a:extLst>
+          </p:spPr>
+          <p:txBody>
+            <a:bodyPr vert="horz" wrap="square" lIns="91440" tIns="45720" rIns="91440" bIns="45720" numCol="1" anchor="t" anchorCtr="0" compatLnSpc="1">
+              <a:prstTxWarp prst="textNoShape">
+                <a:avLst/>
+              </a:prstTxWarp>
+            </a:bodyPr>
+            <a:lstStyle/>
+            <a:p>
+              <a:endParaRPr lang="en-US" sz="900" dirty="0"/>
+            </a:p>
+          </p:txBody>
+        </p:sp>
+        <p:sp>
+          <p:nvSpPr>
+            <p:cNvPr id="26" name="Freeform 9">
+              <a:extLst>
+                <a:ext uri="{FF2B5EF4-FFF2-40B4-BE49-F238E27FC236}">
+                  <a16:creationId xmlns:a16="http://schemas.microsoft.com/office/drawing/2014/main" id="{EF1231E0-2758-B5E8-D790-75F600B847EE}"/>
+                </a:ext>
+              </a:extLst>
+            </p:cNvPr>
+            <p:cNvSpPr>
+              <a:spLocks/>
+            </p:cNvSpPr>
+            <p:nvPr userDrawn="1"/>
+          </p:nvSpPr>
+          <p:spPr bwMode="auto">
+            <a:xfrm>
+              <a:off x="6369" y="3473"/>
+              <a:ext cx="1098" cy="1694"/>
+            </a:xfrm>
+            <a:custGeom>
+              <a:avLst/>
+              <a:gdLst>
+                <a:gd name="T0" fmla="*/ 0 w 1098"/>
+                <a:gd name="T1" fmla="*/ 0 h 1694"/>
+                <a:gd name="T2" fmla="*/ 0 w 1098"/>
+                <a:gd name="T3" fmla="*/ 1694 h 1694"/>
+                <a:gd name="T4" fmla="*/ 1098 w 1098"/>
+                <a:gd name="T5" fmla="*/ 1694 h 1694"/>
+                <a:gd name="T6" fmla="*/ 1098 w 1098"/>
+                <a:gd name="T7" fmla="*/ 1397 h 1694"/>
+                <a:gd name="T8" fmla="*/ 321 w 1098"/>
+                <a:gd name="T9" fmla="*/ 1397 h 1694"/>
+                <a:gd name="T10" fmla="*/ 321 w 1098"/>
+                <a:gd name="T11" fmla="*/ 973 h 1694"/>
+                <a:gd name="T12" fmla="*/ 1030 w 1098"/>
+                <a:gd name="T13" fmla="*/ 973 h 1694"/>
+                <a:gd name="T14" fmla="*/ 1030 w 1098"/>
+                <a:gd name="T15" fmla="*/ 687 h 1694"/>
+                <a:gd name="T16" fmla="*/ 321 w 1098"/>
+                <a:gd name="T17" fmla="*/ 687 h 1694"/>
+                <a:gd name="T18" fmla="*/ 321 w 1098"/>
+                <a:gd name="T19" fmla="*/ 297 h 1694"/>
+                <a:gd name="T20" fmla="*/ 1098 w 1098"/>
+                <a:gd name="T21" fmla="*/ 297 h 1694"/>
+                <a:gd name="T22" fmla="*/ 1098 w 1098"/>
+                <a:gd name="T23" fmla="*/ 0 h 1694"/>
+                <a:gd name="T24" fmla="*/ 0 w 1098"/>
+                <a:gd name="T25" fmla="*/ 0 h 1694"/>
+              </a:gdLst>
+              <a:ahLst/>
+              <a:cxnLst>
+                <a:cxn ang="0">
+                  <a:pos x="T0" y="T1"/>
+                </a:cxn>
+                <a:cxn ang="0">
+                  <a:pos x="T2" y="T3"/>
+                </a:cxn>
+                <a:cxn ang="0">
+                  <a:pos x="T4" y="T5"/>
+                </a:cxn>
+                <a:cxn ang="0">
+                  <a:pos x="T6" y="T7"/>
+                </a:cxn>
+                <a:cxn ang="0">
+                  <a:pos x="T8" y="T9"/>
+                </a:cxn>
+                <a:cxn ang="0">
+                  <a:pos x="T10" y="T11"/>
+                </a:cxn>
+                <a:cxn ang="0">
+                  <a:pos x="T12" y="T13"/>
+                </a:cxn>
+                <a:cxn ang="0">
+                  <a:pos x="T14" y="T15"/>
+                </a:cxn>
+                <a:cxn ang="0">
+                  <a:pos x="T16" y="T17"/>
+                </a:cxn>
+                <a:cxn ang="0">
+                  <a:pos x="T18" y="T19"/>
+                </a:cxn>
+                <a:cxn ang="0">
+                  <a:pos x="T20" y="T21"/>
+                </a:cxn>
+                <a:cxn ang="0">
+                  <a:pos x="T22" y="T23"/>
+                </a:cxn>
+                <a:cxn ang="0">
+                  <a:pos x="T24" y="T25"/>
+                </a:cxn>
+              </a:cxnLst>
+              <a:rect l="0" t="0" r="r" b="b"/>
+              <a:pathLst>
+                <a:path w="1098" h="1694">
+                  <a:moveTo>
+                    <a:pt x="0" y="0"/>
+                  </a:moveTo>
+                  <a:lnTo>
+                    <a:pt x="0" y="1694"/>
+                  </a:lnTo>
+                  <a:lnTo>
+                    <a:pt x="1098" y="1694"/>
+                  </a:lnTo>
+                  <a:lnTo>
+                    <a:pt x="1098" y="1397"/>
+                  </a:lnTo>
+                  <a:lnTo>
+                    <a:pt x="321" y="1397"/>
+                  </a:lnTo>
+                  <a:lnTo>
+                    <a:pt x="321" y="973"/>
+                  </a:lnTo>
+                  <a:lnTo>
+                    <a:pt x="1030" y="973"/>
+                  </a:lnTo>
+                  <a:lnTo>
+                    <a:pt x="1030" y="687"/>
+                  </a:lnTo>
+                  <a:lnTo>
+                    <a:pt x="321" y="687"/>
+                  </a:lnTo>
+                  <a:lnTo>
+                    <a:pt x="321" y="297"/>
+                  </a:lnTo>
+                  <a:lnTo>
+                    <a:pt x="1098" y="297"/>
+                  </a:lnTo>
+                  <a:lnTo>
+                    <a:pt x="1098" y="0"/>
+                  </a:lnTo>
+                  <a:lnTo>
+                    <a:pt x="0" y="0"/>
+                  </a:lnTo>
+                  <a:close/>
+                </a:path>
+              </a:pathLst>
+            </a:custGeom>
+            <a:grpFill/>
+            <a:ln>
+              <a:noFill/>
+            </a:ln>
+            <a:extLst>
+              <a:ext uri="{91240B29-F687-4F45-9708-019B960494DF}">
+                <a14:hiddenLine xmlns:a14="http://schemas.microsoft.com/office/drawing/2010/main" w="9525">
+                  <a:solidFill>
+                    <a:srgbClr val="000000"/>
+                  </a:solidFill>
+                  <a:round/>
+                  <a:headEnd/>
+                  <a:tailEnd/>
+                </a14:hiddenLine>
+              </a:ext>
+            </a:extLst>
+          </p:spPr>
+          <p:txBody>
+            <a:bodyPr vert="horz" wrap="square" lIns="91440" tIns="45720" rIns="91440" bIns="45720" numCol="1" anchor="t" anchorCtr="0" compatLnSpc="1">
+              <a:prstTxWarp prst="textNoShape">
+                <a:avLst/>
+              </a:prstTxWarp>
+            </a:bodyPr>
+            <a:lstStyle/>
+            <a:p>
+              <a:endParaRPr lang="en-US" sz="900"/>
+            </a:p>
+          </p:txBody>
+        </p:sp>
+        <p:sp>
+          <p:nvSpPr>
+            <p:cNvPr id="27" name="Freeform 10">
+              <a:extLst>
+                <a:ext uri="{FF2B5EF4-FFF2-40B4-BE49-F238E27FC236}">
+                  <a16:creationId xmlns:a16="http://schemas.microsoft.com/office/drawing/2014/main" id="{3F0FFF12-BDD5-55EF-D357-8928C1087787}"/>
+                </a:ext>
+              </a:extLst>
+            </p:cNvPr>
+            <p:cNvSpPr>
+              <a:spLocks noEditPoints="1"/>
+            </p:cNvSpPr>
+            <p:nvPr userDrawn="1"/>
+          </p:nvSpPr>
+          <p:spPr bwMode="auto">
+            <a:xfrm>
+              <a:off x="4481" y="3473"/>
+              <a:ext cx="1215" cy="1694"/>
+            </a:xfrm>
+            <a:custGeom>
+              <a:avLst/>
+              <a:gdLst>
+                <a:gd name="T0" fmla="*/ 406 w 860"/>
+                <a:gd name="T1" fmla="*/ 791 h 1199"/>
+                <a:gd name="T2" fmla="*/ 227 w 860"/>
+                <a:gd name="T3" fmla="*/ 791 h 1199"/>
+                <a:gd name="T4" fmla="*/ 227 w 860"/>
+                <a:gd name="T5" fmla="*/ 1199 h 1199"/>
+                <a:gd name="T6" fmla="*/ 0 w 860"/>
+                <a:gd name="T7" fmla="*/ 1199 h 1199"/>
+                <a:gd name="T8" fmla="*/ 0 w 860"/>
+                <a:gd name="T9" fmla="*/ 0 h 1199"/>
+                <a:gd name="T10" fmla="*/ 406 w 860"/>
+                <a:gd name="T11" fmla="*/ 0 h 1199"/>
+                <a:gd name="T12" fmla="*/ 860 w 860"/>
+                <a:gd name="T13" fmla="*/ 396 h 1199"/>
+                <a:gd name="T14" fmla="*/ 406 w 860"/>
+                <a:gd name="T15" fmla="*/ 791 h 1199"/>
+                <a:gd name="T16" fmla="*/ 394 w 860"/>
+                <a:gd name="T17" fmla="*/ 194 h 1199"/>
+                <a:gd name="T18" fmla="*/ 227 w 860"/>
+                <a:gd name="T19" fmla="*/ 194 h 1199"/>
+                <a:gd name="T20" fmla="*/ 227 w 860"/>
+                <a:gd name="T21" fmla="*/ 598 h 1199"/>
+                <a:gd name="T22" fmla="*/ 394 w 860"/>
+                <a:gd name="T23" fmla="*/ 598 h 1199"/>
+                <a:gd name="T24" fmla="*/ 621 w 860"/>
+                <a:gd name="T25" fmla="*/ 396 h 1199"/>
+                <a:gd name="T26" fmla="*/ 394 w 860"/>
+                <a:gd name="T27" fmla="*/ 194 h 1199"/>
+              </a:gdLst>
+              <a:ahLst/>
+              <a:cxnLst>
+                <a:cxn ang="0">
+                  <a:pos x="T0" y="T1"/>
+                </a:cxn>
+                <a:cxn ang="0">
+                  <a:pos x="T2" y="T3"/>
+                </a:cxn>
+                <a:cxn ang="0">
+                  <a:pos x="T4" y="T5"/>
+                </a:cxn>
+                <a:cxn ang="0">
+                  <a:pos x="T6" y="T7"/>
+                </a:cxn>
+                <a:cxn ang="0">
+                  <a:pos x="T8" y="T9"/>
+                </a:cxn>
+                <a:cxn ang="0">
+                  <a:pos x="T10" y="T11"/>
+                </a:cxn>
+                <a:cxn ang="0">
+                  <a:pos x="T12" y="T13"/>
+                </a:cxn>
+                <a:cxn ang="0">
+                  <a:pos x="T14" y="T15"/>
+                </a:cxn>
+                <a:cxn ang="0">
+                  <a:pos x="T16" y="T17"/>
+                </a:cxn>
+                <a:cxn ang="0">
+                  <a:pos x="T18" y="T19"/>
+                </a:cxn>
+                <a:cxn ang="0">
+                  <a:pos x="T20" y="T21"/>
+                </a:cxn>
+                <a:cxn ang="0">
+                  <a:pos x="T22" y="T23"/>
+                </a:cxn>
+                <a:cxn ang="0">
+                  <a:pos x="T24" y="T25"/>
+                </a:cxn>
+                <a:cxn ang="0">
+                  <a:pos x="T26" y="T27"/>
+                </a:cxn>
+              </a:cxnLst>
+              <a:rect l="0" t="0" r="r" b="b"/>
+              <a:pathLst>
+                <a:path w="860" h="1199">
+                  <a:moveTo>
+                    <a:pt x="406" y="791"/>
+                  </a:moveTo>
+                  <a:cubicBezTo>
+                    <a:pt x="227" y="791"/>
+                    <a:pt x="227" y="791"/>
+                    <a:pt x="227" y="791"/>
+                  </a:cubicBezTo>
+                  <a:cubicBezTo>
+                    <a:pt x="227" y="1199"/>
+                    <a:pt x="227" y="1199"/>
+                    <a:pt x="227" y="1199"/>
+                  </a:cubicBezTo>
+                  <a:cubicBezTo>
+                    <a:pt x="0" y="1199"/>
+                    <a:pt x="0" y="1199"/>
+                    <a:pt x="0" y="1199"/>
+                  </a:cubicBezTo>
+                  <a:cubicBezTo>
+                    <a:pt x="0" y="0"/>
+                    <a:pt x="0" y="0"/>
+                    <a:pt x="0" y="0"/>
+                  </a:cubicBezTo>
+                  <a:cubicBezTo>
+                    <a:pt x="406" y="0"/>
+                    <a:pt x="406" y="0"/>
+                    <a:pt x="406" y="0"/>
+                  </a:cubicBezTo>
+                  <a:cubicBezTo>
+                    <a:pt x="661" y="0"/>
+                    <a:pt x="860" y="116"/>
+                    <a:pt x="860" y="396"/>
+                  </a:cubicBezTo>
+                  <a:cubicBezTo>
+                    <a:pt x="860" y="671"/>
+                    <a:pt x="659" y="791"/>
+                    <a:pt x="406" y="791"/>
+                  </a:cubicBezTo>
+                  <a:moveTo>
+                    <a:pt x="394" y="194"/>
+                  </a:moveTo>
+                  <a:cubicBezTo>
+                    <a:pt x="227" y="194"/>
+                    <a:pt x="227" y="194"/>
+                    <a:pt x="227" y="194"/>
+                  </a:cubicBezTo>
+                  <a:cubicBezTo>
+                    <a:pt x="227" y="598"/>
+                    <a:pt x="227" y="598"/>
+                    <a:pt x="227" y="598"/>
+                  </a:cubicBezTo>
+                  <a:cubicBezTo>
+                    <a:pt x="394" y="598"/>
+                    <a:pt x="394" y="598"/>
+                    <a:pt x="394" y="598"/>
+                  </a:cubicBezTo>
+                  <a:cubicBezTo>
+                    <a:pt x="525" y="598"/>
+                    <a:pt x="621" y="534"/>
+                    <a:pt x="621" y="396"/>
+                  </a:cubicBezTo>
+                  <a:cubicBezTo>
+                    <a:pt x="621" y="252"/>
+                    <a:pt x="525" y="194"/>
+                    <a:pt x="394" y="194"/>
+                  </a:cubicBezTo>
+                </a:path>
+              </a:pathLst>
+            </a:custGeom>
+            <a:grpFill/>
+            <a:ln>
+              <a:noFill/>
+            </a:ln>
+            <a:extLst>
+              <a:ext uri="{91240B29-F687-4F45-9708-019B960494DF}">
+                <a14:hiddenLine xmlns:a14="http://schemas.microsoft.com/office/drawing/2010/main" w="9525">
+                  <a:solidFill>
+                    <a:srgbClr val="000000"/>
+                  </a:solidFill>
+                  <a:round/>
+                  <a:headEnd/>
+                  <a:tailEnd/>
+                </a14:hiddenLine>
+              </a:ext>
+            </a:extLst>
+          </p:spPr>
+          <p:txBody>
+            <a:bodyPr vert="horz" wrap="square" lIns="91440" tIns="45720" rIns="91440" bIns="45720" numCol="1" anchor="t" anchorCtr="0" compatLnSpc="1">
+              <a:prstTxWarp prst="textNoShape">
+                <a:avLst/>
+              </a:prstTxWarp>
+            </a:bodyPr>
+            <a:lstStyle/>
+            <a:p>
+              <a:endParaRPr lang="en-US" sz="900"/>
+            </a:p>
+          </p:txBody>
+        </p:sp>
+        <p:sp>
+          <p:nvSpPr>
+            <p:cNvPr id="28" name="Freeform 11">
+              <a:extLst>
+                <a:ext uri="{FF2B5EF4-FFF2-40B4-BE49-F238E27FC236}">
+                  <a16:creationId xmlns:a16="http://schemas.microsoft.com/office/drawing/2014/main" id="{9508BD5F-824F-72C6-ED32-9F2A771CC30D}"/>
+                </a:ext>
+              </a:extLst>
+            </p:cNvPr>
+            <p:cNvSpPr>
+              <a:spLocks/>
+            </p:cNvSpPr>
+            <p:nvPr userDrawn="1"/>
+          </p:nvSpPr>
+          <p:spPr bwMode="auto">
+            <a:xfrm>
+              <a:off x="1945" y="3473"/>
+              <a:ext cx="1720" cy="1694"/>
+            </a:xfrm>
+            <a:custGeom>
+              <a:avLst/>
+              <a:gdLst>
+                <a:gd name="T0" fmla="*/ 1265 w 1720"/>
+                <a:gd name="T1" fmla="*/ 0 h 1694"/>
+                <a:gd name="T2" fmla="*/ 860 w 1720"/>
+                <a:gd name="T3" fmla="*/ 996 h 1694"/>
+                <a:gd name="T4" fmla="*/ 456 w 1720"/>
+                <a:gd name="T5" fmla="*/ 0 h 1694"/>
+                <a:gd name="T6" fmla="*/ 0 w 1720"/>
+                <a:gd name="T7" fmla="*/ 0 h 1694"/>
+                <a:gd name="T8" fmla="*/ 0 w 1720"/>
+                <a:gd name="T9" fmla="*/ 1694 h 1694"/>
+                <a:gd name="T10" fmla="*/ 303 w 1720"/>
+                <a:gd name="T11" fmla="*/ 1694 h 1694"/>
+                <a:gd name="T12" fmla="*/ 303 w 1720"/>
+                <a:gd name="T13" fmla="*/ 428 h 1694"/>
+                <a:gd name="T14" fmla="*/ 692 w 1720"/>
+                <a:gd name="T15" fmla="*/ 1321 h 1694"/>
+                <a:gd name="T16" fmla="*/ 709 w 1720"/>
+                <a:gd name="T17" fmla="*/ 1321 h 1694"/>
+                <a:gd name="T18" fmla="*/ 1012 w 1720"/>
+                <a:gd name="T19" fmla="*/ 1321 h 1694"/>
+                <a:gd name="T20" fmla="*/ 1029 w 1720"/>
+                <a:gd name="T21" fmla="*/ 1321 h 1694"/>
+                <a:gd name="T22" fmla="*/ 1416 w 1720"/>
+                <a:gd name="T23" fmla="*/ 428 h 1694"/>
+                <a:gd name="T24" fmla="*/ 1416 w 1720"/>
+                <a:gd name="T25" fmla="*/ 1694 h 1694"/>
+                <a:gd name="T26" fmla="*/ 1720 w 1720"/>
+                <a:gd name="T27" fmla="*/ 1694 h 1694"/>
+                <a:gd name="T28" fmla="*/ 1720 w 1720"/>
+                <a:gd name="T29" fmla="*/ 0 h 1694"/>
+                <a:gd name="T30" fmla="*/ 1265 w 1720"/>
+                <a:gd name="T31" fmla="*/ 0 h 1694"/>
+              </a:gdLst>
+              <a:ahLst/>
+              <a:cxnLst>
+                <a:cxn ang="0">
+                  <a:pos x="T0" y="T1"/>
+                </a:cxn>
+                <a:cxn ang="0">
+                  <a:pos x="T2" y="T3"/>
+                </a:cxn>
+                <a:cxn ang="0">
+                  <a:pos x="T4" y="T5"/>
+                </a:cxn>
+                <a:cxn ang="0">
+                  <a:pos x="T6" y="T7"/>
+                </a:cxn>
+                <a:cxn ang="0">
+                  <a:pos x="T8" y="T9"/>
+                </a:cxn>
+                <a:cxn ang="0">
+                  <a:pos x="T10" y="T11"/>
+                </a:cxn>
+                <a:cxn ang="0">
+                  <a:pos x="T12" y="T13"/>
+                </a:cxn>
+                <a:cxn ang="0">
+                  <a:pos x="T14" y="T15"/>
+                </a:cxn>
+                <a:cxn ang="0">
+                  <a:pos x="T16" y="T17"/>
+                </a:cxn>
+                <a:cxn ang="0">
+                  <a:pos x="T18" y="T19"/>
+                </a:cxn>
+                <a:cxn ang="0">
+                  <a:pos x="T20" y="T21"/>
+                </a:cxn>
+                <a:cxn ang="0">
+                  <a:pos x="T22" y="T23"/>
+                </a:cxn>
+                <a:cxn ang="0">
+                  <a:pos x="T24" y="T25"/>
+                </a:cxn>
+                <a:cxn ang="0">
+                  <a:pos x="T26" y="T27"/>
+                </a:cxn>
+                <a:cxn ang="0">
+                  <a:pos x="T28" y="T29"/>
+                </a:cxn>
+                <a:cxn ang="0">
+                  <a:pos x="T30" y="T31"/>
+                </a:cxn>
+              </a:cxnLst>
+              <a:rect l="0" t="0" r="r" b="b"/>
+              <a:pathLst>
+                <a:path w="1720" h="1694">
+                  <a:moveTo>
+                    <a:pt x="1265" y="0"/>
+                  </a:moveTo>
+                  <a:lnTo>
+                    <a:pt x="860" y="996"/>
+                  </a:lnTo>
+                  <a:lnTo>
+                    <a:pt x="456" y="0"/>
+                  </a:lnTo>
+                  <a:lnTo>
+                    <a:pt x="0" y="0"/>
+                  </a:lnTo>
+                  <a:lnTo>
+                    <a:pt x="0" y="1694"/>
+                  </a:lnTo>
+                  <a:lnTo>
+                    <a:pt x="303" y="1694"/>
+                  </a:lnTo>
+                  <a:lnTo>
+                    <a:pt x="303" y="428"/>
+                  </a:lnTo>
+                  <a:lnTo>
+                    <a:pt x="692" y="1321"/>
+                  </a:lnTo>
+                  <a:lnTo>
+                    <a:pt x="709" y="1321"/>
+                  </a:lnTo>
+                  <a:lnTo>
+                    <a:pt x="1012" y="1321"/>
+                  </a:lnTo>
+                  <a:lnTo>
+                    <a:pt x="1029" y="1321"/>
+                  </a:lnTo>
+                  <a:lnTo>
+                    <a:pt x="1416" y="428"/>
+                  </a:lnTo>
+                  <a:lnTo>
+                    <a:pt x="1416" y="1694"/>
+                  </a:lnTo>
+                  <a:lnTo>
+                    <a:pt x="1720" y="1694"/>
+                  </a:lnTo>
+                  <a:lnTo>
+                    <a:pt x="1720" y="0"/>
+                  </a:lnTo>
+                  <a:lnTo>
+                    <a:pt x="1265" y="0"/>
+                  </a:lnTo>
+                  <a:close/>
+                </a:path>
+              </a:pathLst>
+            </a:custGeom>
+            <a:grpFill/>
+            <a:ln>
+              <a:noFill/>
+            </a:ln>
+            <a:extLst>
+              <a:ext uri="{91240B29-F687-4F45-9708-019B960494DF}">
+                <a14:hiddenLine xmlns:a14="http://schemas.microsoft.com/office/drawing/2010/main" w="9525">
+                  <a:solidFill>
+                    <a:srgbClr val="000000"/>
+                  </a:solidFill>
+                  <a:round/>
+                  <a:headEnd/>
+                  <a:tailEnd/>
+                </a14:hiddenLine>
+              </a:ext>
+            </a:extLst>
+          </p:spPr>
+          <p:txBody>
+            <a:bodyPr vert="horz" wrap="square" lIns="91440" tIns="45720" rIns="91440" bIns="45720" numCol="1" anchor="t" anchorCtr="0" compatLnSpc="1">
+              <a:prstTxWarp prst="textNoShape">
+                <a:avLst/>
+              </a:prstTxWarp>
+            </a:bodyPr>
+            <a:lstStyle/>
+            <a:p>
+              <a:endParaRPr lang="en-US" sz="900" dirty="0"/>
+            </a:p>
+          </p:txBody>
+        </p:sp>
+        <p:sp>
+          <p:nvSpPr>
+            <p:cNvPr id="29" name="Freeform 12">
+              <a:extLst>
+                <a:ext uri="{FF2B5EF4-FFF2-40B4-BE49-F238E27FC236}">
+                  <a16:creationId xmlns:a16="http://schemas.microsoft.com/office/drawing/2014/main" id="{551F30CE-9C47-22EE-87A3-B60F10BB5E7F}"/>
+                </a:ext>
+              </a:extLst>
+            </p:cNvPr>
+            <p:cNvSpPr>
+              <a:spLocks/>
+            </p:cNvSpPr>
+            <p:nvPr userDrawn="1"/>
+          </p:nvSpPr>
+          <p:spPr bwMode="auto">
+            <a:xfrm>
+              <a:off x="0" y="3473"/>
+              <a:ext cx="1113" cy="1694"/>
+            </a:xfrm>
+            <a:custGeom>
+              <a:avLst/>
+              <a:gdLst>
+                <a:gd name="T0" fmla="*/ 0 w 1113"/>
+                <a:gd name="T1" fmla="*/ 0 h 1694"/>
+                <a:gd name="T2" fmla="*/ 0 w 1113"/>
+                <a:gd name="T3" fmla="*/ 297 h 1694"/>
+                <a:gd name="T4" fmla="*/ 397 w 1113"/>
+                <a:gd name="T5" fmla="*/ 297 h 1694"/>
+                <a:gd name="T6" fmla="*/ 397 w 1113"/>
+                <a:gd name="T7" fmla="*/ 1397 h 1694"/>
+                <a:gd name="T8" fmla="*/ 0 w 1113"/>
+                <a:gd name="T9" fmla="*/ 1397 h 1694"/>
+                <a:gd name="T10" fmla="*/ 0 w 1113"/>
+                <a:gd name="T11" fmla="*/ 1694 h 1694"/>
+                <a:gd name="T12" fmla="*/ 1113 w 1113"/>
+                <a:gd name="T13" fmla="*/ 1694 h 1694"/>
+                <a:gd name="T14" fmla="*/ 1113 w 1113"/>
+                <a:gd name="T15" fmla="*/ 1397 h 1694"/>
+                <a:gd name="T16" fmla="*/ 717 w 1113"/>
+                <a:gd name="T17" fmla="*/ 1397 h 1694"/>
+                <a:gd name="T18" fmla="*/ 717 w 1113"/>
+                <a:gd name="T19" fmla="*/ 297 h 1694"/>
+                <a:gd name="T20" fmla="*/ 1113 w 1113"/>
+                <a:gd name="T21" fmla="*/ 297 h 1694"/>
+                <a:gd name="T22" fmla="*/ 1113 w 1113"/>
+                <a:gd name="T23" fmla="*/ 0 h 1694"/>
+                <a:gd name="T24" fmla="*/ 0 w 1113"/>
+                <a:gd name="T25" fmla="*/ 0 h 1694"/>
+              </a:gdLst>
+              <a:ahLst/>
+              <a:cxnLst>
+                <a:cxn ang="0">
+                  <a:pos x="T0" y="T1"/>
+                </a:cxn>
+                <a:cxn ang="0">
+                  <a:pos x="T2" y="T3"/>
+                </a:cxn>
+                <a:cxn ang="0">
+                  <a:pos x="T4" y="T5"/>
+                </a:cxn>
+                <a:cxn ang="0">
+                  <a:pos x="T6" y="T7"/>
+                </a:cxn>
+                <a:cxn ang="0">
+                  <a:pos x="T8" y="T9"/>
+                </a:cxn>
+                <a:cxn ang="0">
+                  <a:pos x="T10" y="T11"/>
+                </a:cxn>
+                <a:cxn ang="0">
+                  <a:pos x="T12" y="T13"/>
+                </a:cxn>
+                <a:cxn ang="0">
+                  <a:pos x="T14" y="T15"/>
+                </a:cxn>
+                <a:cxn ang="0">
+                  <a:pos x="T16" y="T17"/>
+                </a:cxn>
+                <a:cxn ang="0">
+                  <a:pos x="T18" y="T19"/>
+                </a:cxn>
+                <a:cxn ang="0">
+                  <a:pos x="T20" y="T21"/>
+                </a:cxn>
+                <a:cxn ang="0">
+                  <a:pos x="T22" y="T23"/>
+                </a:cxn>
+                <a:cxn ang="0">
+                  <a:pos x="T24" y="T25"/>
+                </a:cxn>
+              </a:cxnLst>
+              <a:rect l="0" t="0" r="r" b="b"/>
+              <a:pathLst>
+                <a:path w="1113" h="1694">
+                  <a:moveTo>
+                    <a:pt x="0" y="0"/>
+                  </a:moveTo>
+                  <a:lnTo>
+                    <a:pt x="0" y="297"/>
+                  </a:lnTo>
+                  <a:lnTo>
+                    <a:pt x="397" y="297"/>
+                  </a:lnTo>
+                  <a:lnTo>
+                    <a:pt x="397" y="1397"/>
+                  </a:lnTo>
+                  <a:lnTo>
+                    <a:pt x="0" y="1397"/>
+                  </a:lnTo>
+                  <a:lnTo>
+                    <a:pt x="0" y="1694"/>
+                  </a:lnTo>
+                  <a:lnTo>
+                    <a:pt x="1113" y="1694"/>
+                  </a:lnTo>
+                  <a:lnTo>
+                    <a:pt x="1113" y="1397"/>
+                  </a:lnTo>
+                  <a:lnTo>
+                    <a:pt x="717" y="1397"/>
+                  </a:lnTo>
+                  <a:lnTo>
+                    <a:pt x="717" y="297"/>
+                  </a:lnTo>
+                  <a:lnTo>
+                    <a:pt x="1113" y="297"/>
+                  </a:lnTo>
+                  <a:lnTo>
+                    <a:pt x="1113" y="0"/>
+                  </a:lnTo>
+                  <a:lnTo>
+                    <a:pt x="0" y="0"/>
+                  </a:lnTo>
+                  <a:close/>
+                </a:path>
+              </a:pathLst>
+            </a:custGeom>
+            <a:grpFill/>
+            <a:ln>
+              <a:noFill/>
+            </a:ln>
+            <a:extLst>
+              <a:ext uri="{91240B29-F687-4F45-9708-019B960494DF}">
+                <a14:hiddenLine xmlns:a14="http://schemas.microsoft.com/office/drawing/2010/main" w="9525">
+                  <a:solidFill>
+                    <a:srgbClr val="000000"/>
+                  </a:solidFill>
+                  <a:round/>
+                  <a:headEnd/>
+                  <a:tailEnd/>
+                </a14:hiddenLine>
+              </a:ext>
+            </a:extLst>
+          </p:spPr>
+          <p:txBody>
+            <a:bodyPr vert="horz" wrap="square" lIns="91440" tIns="45720" rIns="91440" bIns="45720" numCol="1" anchor="t" anchorCtr="0" compatLnSpc="1">
+              <a:prstTxWarp prst="textNoShape">
+                <a:avLst/>
+              </a:prstTxWarp>
+            </a:bodyPr>
+            <a:lstStyle/>
+            <a:p>
+              <a:endParaRPr lang="en-US" sz="900"/>
+            </a:p>
+          </p:txBody>
+        </p:sp>
+      </p:grpSp>
     </p:spTree>
     <p:extLst>
       <p:ext uri="{BB962C8B-B14F-4D97-AF65-F5344CB8AC3E}">
@@ -37761,9 +39335,18 @@
   <p:clrMapOvr>
     <a:masterClrMapping/>
   </p:clrMapOvr>
-  <p:transition>
-    <p:fade/>
-  </p:transition>
+  <mc:AlternateContent xmlns:mc="http://schemas.openxmlformats.org/markup-compatibility/2006">
+    <mc:Choice xmlns:p159="http://schemas.microsoft.com/office/powerpoint/2015/09/main" Requires="p159">
+      <p:transition xmlns:p14="http://schemas.microsoft.com/office/powerpoint/2010/main" spd="slow" p14:dur="2000">
+        <p159:morph option="byObject"/>
+      </p:transition>
+    </mc:Choice>
+    <mc:Fallback>
+      <p:transition spd="slow">
+        <p:fade/>
+      </p:transition>
+    </mc:Fallback>
+  </mc:AlternateContent>
 </p:sldLayout>
 </file>
 
@@ -40017,13 +41600,7 @@
   <p:cSld>
     <p:spTree>
       <p:nvGrpSpPr>
-        <p:cNvPr id="1" name="">
-          <a:extLst>
-            <a:ext uri="{FF2B5EF4-FFF2-40B4-BE49-F238E27FC236}">
-              <a16:creationId xmlns:a16="http://schemas.microsoft.com/office/drawing/2014/main" id="{00F7CC57-32B4-5651-C726-27956387C3E7}"/>
-            </a:ext>
-          </a:extLst>
-        </p:cNvPr>
+        <p:cNvPr id="1" name=""/>
         <p:cNvGrpSpPr/>
         <p:nvPr/>
       </p:nvGrpSpPr>
@@ -40037,63 +41614,265 @@
       </p:grpSpPr>
       <p:sp>
         <p:nvSpPr>
-          <p:cNvPr id="2" name="Title 1">
-            <a:extLst>
-              <a:ext uri="{FF2B5EF4-FFF2-40B4-BE49-F238E27FC236}">
-                <a16:creationId xmlns:a16="http://schemas.microsoft.com/office/drawing/2014/main" id="{60380337-D626-AC7B-5E8D-3144BB486543}"/>
-              </a:ext>
-            </a:extLst>
-          </p:cNvPr>
-          <p:cNvSpPr>
-            <a:spLocks noGrp="1"/>
+          <p:cNvPr id="8" name="Title 1">
+            <a:extLst>
+              <a:ext uri="{FF2B5EF4-FFF2-40B4-BE49-F238E27FC236}">
+                <a16:creationId xmlns:a16="http://schemas.microsoft.com/office/drawing/2014/main" id="{899BED41-5E7D-100D-DC81-72C6A6EA4DD6}"/>
+              </a:ext>
+            </a:extLst>
+          </p:cNvPr>
+          <p:cNvSpPr txBox="1">
+            <a:spLocks/>
           </p:cNvSpPr>
-          <p:nvPr>
-            <p:ph type="ctrTitle"/>
-          </p:nvPr>
+          <p:nvPr/>
         </p:nvSpPr>
         <p:spPr>
           <a:xfrm>
             <a:off x="330271" y="918580"/>
             <a:ext cx="9144000" cy="1847942"/>
           </a:xfrm>
+          <a:prstGeom prst="rect">
+            <a:avLst/>
+          </a:prstGeom>
         </p:spPr>
         <p:txBody>
-          <a:bodyPr/>
-          <a:lstStyle/>
-          <a:p>
-            <a:r>
-              <a:rPr lang="en-GB" b="1" dirty="0"/>
+          <a:bodyPr vert="horz" lIns="0" tIns="0" rIns="0" bIns="0" rtlCol="0" anchor="b">
+            <a:noAutofit/>
+          </a:bodyPr>
+          <a:lstStyle>
+            <a:lvl1pPr algn="l" defTabSz="685765" rtl="0" eaLnBrk="1" latinLnBrk="0" hangingPunct="1">
+              <a:lnSpc>
+                <a:spcPct val="90000"/>
+              </a:lnSpc>
+              <a:spcBef>
+                <a:spcPct val="0"/>
+              </a:spcBef>
+              <a:buNone/>
+              <a:defRPr sz="6400" b="0" kern="1200">
+                <a:solidFill>
+                  <a:schemeClr val="accent1"/>
+                </a:solidFill>
+                <a:latin typeface="+mj-lt"/>
+                <a:ea typeface="+mj-ea"/>
+                <a:cs typeface="+mj-cs"/>
+              </a:defRPr>
+            </a:lvl1pPr>
+          </a:lstStyle>
+          <a:p>
+            <a:r>
+              <a:rPr lang="en-GB" b="1"/>
               <a:t>FYP Interim Presentation</a:t>
             </a:r>
+            <a:endParaRPr lang="en-GB" b="1" dirty="0"/>
           </a:p>
         </p:txBody>
       </p:sp>
       <p:sp>
         <p:nvSpPr>
-          <p:cNvPr id="3" name="Subtitle 2">
-            <a:extLst>
-              <a:ext uri="{FF2B5EF4-FFF2-40B4-BE49-F238E27FC236}">
-                <a16:creationId xmlns:a16="http://schemas.microsoft.com/office/drawing/2014/main" id="{8B7FCD95-DD6E-BAAA-DD32-3D1E187DA719}"/>
-              </a:ext>
-            </a:extLst>
-          </p:cNvPr>
-          <p:cNvSpPr>
-            <a:spLocks noGrp="1"/>
+          <p:cNvPr id="9" name="Subtitle 2">
+            <a:extLst>
+              <a:ext uri="{FF2B5EF4-FFF2-40B4-BE49-F238E27FC236}">
+                <a16:creationId xmlns:a16="http://schemas.microsoft.com/office/drawing/2014/main" id="{16CB6D1B-C2D1-5385-948E-4447D7A3C31E}"/>
+              </a:ext>
+            </a:extLst>
+          </p:cNvPr>
+          <p:cNvSpPr txBox="1">
+            <a:spLocks/>
           </p:cNvSpPr>
-          <p:nvPr>
-            <p:ph type="subTitle" idx="1"/>
-          </p:nvPr>
+          <p:nvPr/>
         </p:nvSpPr>
         <p:spPr>
           <a:xfrm>
-            <a:off x="330271" y="2766521"/>
+            <a:off x="354435" y="2906299"/>
             <a:ext cx="11111656" cy="2497241"/>
           </a:xfrm>
+          <a:prstGeom prst="rect">
+            <a:avLst/>
+          </a:prstGeom>
         </p:spPr>
         <p:txBody>
-          <a:bodyPr/>
-          <a:lstStyle/>
-          <a:p>
+          <a:bodyPr vert="horz" lIns="0" tIns="0" rIns="0" bIns="0" rtlCol="0">
+            <a:noAutofit/>
+          </a:bodyPr>
+          <a:lstStyle>
+            <a:lvl1pPr marL="0" indent="0" algn="l" defTabSz="685765" rtl="0" eaLnBrk="1" latinLnBrk="0" hangingPunct="1">
+              <a:lnSpc>
+                <a:spcPct val="105000"/>
+              </a:lnSpc>
+              <a:spcBef>
+                <a:spcPts val="0"/>
+              </a:spcBef>
+              <a:buFont typeface="Arial" panose="020B0604020202020204" pitchFamily="34" charset="0"/>
+              <a:buNone/>
+              <a:defRPr sz="4800" kern="1200">
+                <a:solidFill>
+                  <a:schemeClr val="accent1"/>
+                </a:solidFill>
+                <a:latin typeface="+mn-lt"/>
+                <a:ea typeface="Inter Medium" panose="02000503000000020004" pitchFamily="2" charset="0"/>
+                <a:cs typeface="+mn-cs"/>
+              </a:defRPr>
+            </a:lvl1pPr>
+            <a:lvl2pPr marL="342882" indent="0" algn="ctr" defTabSz="685765" rtl="0" eaLnBrk="1" latinLnBrk="0" hangingPunct="1">
+              <a:lnSpc>
+                <a:spcPct val="105000"/>
+              </a:lnSpc>
+              <a:spcBef>
+                <a:spcPts val="0"/>
+              </a:spcBef>
+              <a:buFont typeface="Arial" panose="020B0604020202020204" pitchFamily="34" charset="0"/>
+              <a:buNone/>
+              <a:defRPr sz="1500" b="0" kern="1200">
+                <a:solidFill>
+                  <a:schemeClr val="tx1"/>
+                </a:solidFill>
+                <a:latin typeface="+mj-lt"/>
+                <a:ea typeface="+mn-ea"/>
+                <a:cs typeface="+mn-cs"/>
+              </a:defRPr>
+            </a:lvl2pPr>
+            <a:lvl3pPr marL="685765" indent="0" algn="ctr" defTabSz="685765" rtl="0" eaLnBrk="1" latinLnBrk="0" hangingPunct="1">
+              <a:lnSpc>
+                <a:spcPct val="105000"/>
+              </a:lnSpc>
+              <a:spcBef>
+                <a:spcPts val="0"/>
+              </a:spcBef>
+              <a:buClr>
+                <a:schemeClr val="accent1"/>
+              </a:buClr>
+              <a:buFont typeface="Arial" panose="020B0604020202020204" pitchFamily="34" charset="0"/>
+              <a:buNone/>
+              <a:defRPr sz="1350" kern="1200">
+                <a:solidFill>
+                  <a:schemeClr val="tx1"/>
+                </a:solidFill>
+                <a:latin typeface="+mn-lt"/>
+                <a:ea typeface="+mn-ea"/>
+                <a:cs typeface="+mn-cs"/>
+              </a:defRPr>
+            </a:lvl3pPr>
+            <a:lvl4pPr marL="1028647" indent="0" algn="ctr" defTabSz="685765" rtl="0" eaLnBrk="1" latinLnBrk="0" hangingPunct="1">
+              <a:lnSpc>
+                <a:spcPct val="105000"/>
+              </a:lnSpc>
+              <a:spcBef>
+                <a:spcPts val="0"/>
+              </a:spcBef>
+              <a:buClr>
+                <a:schemeClr val="accent1"/>
+              </a:buClr>
+              <a:buFont typeface="Arial" panose="020B0604020202020204" pitchFamily="34" charset="0"/>
+              <a:buNone/>
+              <a:defRPr sz="1200" kern="1200">
+                <a:solidFill>
+                  <a:schemeClr val="tx1"/>
+                </a:solidFill>
+                <a:latin typeface="+mn-lt"/>
+                <a:ea typeface="+mn-ea"/>
+                <a:cs typeface="+mn-cs"/>
+              </a:defRPr>
+            </a:lvl4pPr>
+            <a:lvl5pPr marL="1371530" indent="0" algn="ctr" defTabSz="685765" rtl="0" eaLnBrk="1" latinLnBrk="0" hangingPunct="1">
+              <a:lnSpc>
+                <a:spcPct val="105000"/>
+              </a:lnSpc>
+              <a:spcBef>
+                <a:spcPts val="0"/>
+              </a:spcBef>
+              <a:buClr>
+                <a:schemeClr val="accent1"/>
+              </a:buClr>
+              <a:buFont typeface="Arial" panose="020B0604020202020204" pitchFamily="34" charset="0"/>
+              <a:buNone/>
+              <a:defRPr sz="1200" kern="1200">
+                <a:solidFill>
+                  <a:schemeClr val="tx1"/>
+                </a:solidFill>
+                <a:latin typeface="+mn-lt"/>
+                <a:ea typeface="+mn-ea"/>
+                <a:cs typeface="+mn-cs"/>
+              </a:defRPr>
+            </a:lvl5pPr>
+            <a:lvl6pPr marL="1714412" indent="0" algn="ctr" defTabSz="685765" rtl="0" eaLnBrk="1" latinLnBrk="0" hangingPunct="1">
+              <a:lnSpc>
+                <a:spcPct val="90000"/>
+              </a:lnSpc>
+              <a:spcBef>
+                <a:spcPts val="375"/>
+              </a:spcBef>
+              <a:buFont typeface="Arial" panose="020B0604020202020204" pitchFamily="34" charset="0"/>
+              <a:buNone/>
+              <a:defRPr sz="1200" kern="1200">
+                <a:solidFill>
+                  <a:schemeClr val="tx1"/>
+                </a:solidFill>
+                <a:latin typeface="+mn-lt"/>
+                <a:ea typeface="+mn-ea"/>
+                <a:cs typeface="+mn-cs"/>
+              </a:defRPr>
+            </a:lvl6pPr>
+            <a:lvl7pPr marL="2057295" indent="0" algn="ctr" defTabSz="685765" rtl="0" eaLnBrk="1" latinLnBrk="0" hangingPunct="1">
+              <a:lnSpc>
+                <a:spcPct val="90000"/>
+              </a:lnSpc>
+              <a:spcBef>
+                <a:spcPts val="375"/>
+              </a:spcBef>
+              <a:buFont typeface="Arial" panose="020B0604020202020204" pitchFamily="34" charset="0"/>
+              <a:buNone/>
+              <a:defRPr sz="1200" kern="1200">
+                <a:solidFill>
+                  <a:schemeClr val="tx1"/>
+                </a:solidFill>
+                <a:latin typeface="+mn-lt"/>
+                <a:ea typeface="+mn-ea"/>
+                <a:cs typeface="+mn-cs"/>
+              </a:defRPr>
+            </a:lvl7pPr>
+            <a:lvl8pPr marL="2400177" indent="0" algn="ctr" defTabSz="685765" rtl="0" eaLnBrk="1" latinLnBrk="0" hangingPunct="1">
+              <a:lnSpc>
+                <a:spcPct val="90000"/>
+              </a:lnSpc>
+              <a:spcBef>
+                <a:spcPts val="375"/>
+              </a:spcBef>
+              <a:buFont typeface="Arial" panose="020B0604020202020204" pitchFamily="34" charset="0"/>
+              <a:buNone/>
+              <a:defRPr sz="1200" kern="1200">
+                <a:solidFill>
+                  <a:schemeClr val="tx1"/>
+                </a:solidFill>
+                <a:latin typeface="+mn-lt"/>
+                <a:ea typeface="+mn-ea"/>
+                <a:cs typeface="+mn-cs"/>
+              </a:defRPr>
+            </a:lvl8pPr>
+            <a:lvl9pPr marL="2743060" indent="0" algn="ctr" defTabSz="685765" rtl="0" eaLnBrk="1" latinLnBrk="0" hangingPunct="1">
+              <a:lnSpc>
+                <a:spcPct val="90000"/>
+              </a:lnSpc>
+              <a:spcBef>
+                <a:spcPts val="375"/>
+              </a:spcBef>
+              <a:buFont typeface="Arial" panose="020B0604020202020204" pitchFamily="34" charset="0"/>
+              <a:buNone/>
+              <a:defRPr sz="1200" kern="1200">
+                <a:solidFill>
+                  <a:schemeClr val="tx1"/>
+                </a:solidFill>
+                <a:latin typeface="+mn-lt"/>
+                <a:ea typeface="+mn-ea"/>
+                <a:cs typeface="+mn-cs"/>
+              </a:defRPr>
+            </a:lvl9pPr>
+          </a:lstStyle>
+          <a:p>
+            <a:pPr>
+              <a:lnSpc>
+                <a:spcPct val="100000"/>
+              </a:lnSpc>
+            </a:pPr>
             <a:r>
               <a:rPr lang="en-US" i="1" dirty="0"/>
               <a:t>Leveraging Low-Precision Hardware for High-Fidelity CFD: Integrating the Ozaki Scheme into Nektar++</a:t>
@@ -40104,10 +41883,10 @@
       </p:sp>
       <p:sp>
         <p:nvSpPr>
-          <p:cNvPr id="6" name="Text Placeholder 5">
-            <a:extLst>
-              <a:ext uri="{FF2B5EF4-FFF2-40B4-BE49-F238E27FC236}">
-                <a16:creationId xmlns:a16="http://schemas.microsoft.com/office/drawing/2014/main" id="{17ADEF3F-453F-A867-067C-B77BAD46761F}"/>
+          <p:cNvPr id="10" name="Text Placeholder 3">
+            <a:extLst>
+              <a:ext uri="{FF2B5EF4-FFF2-40B4-BE49-F238E27FC236}">
+                <a16:creationId xmlns:a16="http://schemas.microsoft.com/office/drawing/2014/main" id="{997F2ED3-243E-ACE6-A58E-655A7E6E4EE9}"/>
               </a:ext>
             </a:extLst>
           </p:cNvPr>
@@ -40118,19 +41897,30 @@
             <p:ph type="body" sz="quarter" idx="10"/>
           </p:nvPr>
         </p:nvSpPr>
-        <p:spPr/>
+        <p:spPr>
+          <a:xfrm>
+            <a:off x="330271" y="5789336"/>
+            <a:ext cx="5579198" cy="740845"/>
+          </a:xfrm>
+        </p:spPr>
         <p:txBody>
           <a:bodyPr/>
           <a:lstStyle/>
           <a:p>
             <a:r>
-              <a:rPr lang="en-US" dirty="0"/>
+              <a:rPr lang="en-GB" dirty="0"/>
               <a:t>Paul Kallarackel</a:t>
             </a:r>
           </a:p>
           <a:p>
             <a:r>
-              <a:rPr lang="en-US" dirty="0"/>
+              <a:rPr lang="en-GB" dirty="0"/>
+              <a:t>02029025</a:t>
+            </a:r>
+          </a:p>
+          <a:p>
+            <a:r>
+              <a:rPr lang="en-GB" dirty="0"/>
               <a:t>11/03/2026</a:t>
             </a:r>
           </a:p>
@@ -40139,16 +41929,21 @@
     </p:spTree>
     <p:extLst>
       <p:ext uri="{BB962C8B-B14F-4D97-AF65-F5344CB8AC3E}">
-        <p14:creationId xmlns:p14="http://schemas.microsoft.com/office/powerpoint/2010/main" val="3035115975"/>
+        <p14:creationId xmlns:p14="http://schemas.microsoft.com/office/powerpoint/2010/main" val="2390144152"/>
       </p:ext>
     </p:extLst>
   </p:cSld>
   <p:clrMapOvr>
     <a:masterClrMapping/>
   </p:clrMapOvr>
-  <p:transition>
-    <p:fade/>
-  </p:transition>
+  <mc:AlternateContent xmlns:mc="http://schemas.openxmlformats.org/markup-compatibility/2006">
+    <mc:Choice xmlns:p14="http://schemas.microsoft.com/office/powerpoint/2010/main" Requires="p14">
+      <p:transition p14:dur="0"/>
+    </mc:Choice>
+    <mc:Fallback>
+      <p:transition/>
+    </mc:Fallback>
+  </mc:AlternateContent>
 </p:sld>
 </file>
 
@@ -43750,10 +45545,9 @@
           <a:lstStyle/>
           <a:p>
             <a:r>
-              <a:rPr lang="en-GB"/>
+              <a:rPr lang="en-GB" dirty="0"/>
               <a:t>Project LRC001 – Paul Kallarackel - 02029025</a:t>
             </a:r>
-            <a:endParaRPr lang="en-GB" dirty="0"/>
           </a:p>
         </p:txBody>
       </p:sp>
@@ -44107,6 +45901,330 @@
           </a:graphicData>
         </a:graphic>
       </p:graphicFrame>
+      <p:sp>
+        <p:nvSpPr>
+          <p:cNvPr id="8" name="Rectangle: Rounded Corners 7">
+            <a:extLst>
+              <a:ext uri="{FF2B5EF4-FFF2-40B4-BE49-F238E27FC236}">
+                <a16:creationId xmlns:a16="http://schemas.microsoft.com/office/drawing/2014/main" id="{17863353-7429-017E-ED88-17CEE0AA3E76}"/>
+              </a:ext>
+            </a:extLst>
+          </p:cNvPr>
+          <p:cNvSpPr/>
+          <p:nvPr/>
+        </p:nvSpPr>
+        <p:spPr>
+          <a:xfrm>
+            <a:off x="-5572" y="-626533"/>
+            <a:ext cx="4680000" cy="540000"/>
+          </a:xfrm>
+          <a:prstGeom prst="roundRect">
+            <a:avLst/>
+          </a:prstGeom>
+          <a:ln w="28575">
+            <a:noFill/>
+          </a:ln>
+        </p:spPr>
+        <p:style>
+          <a:lnRef idx="2">
+            <a:schemeClr val="accent1">
+              <a:shade val="50000"/>
+            </a:schemeClr>
+          </a:lnRef>
+          <a:fillRef idx="1">
+            <a:schemeClr val="accent1"/>
+          </a:fillRef>
+          <a:effectRef idx="0">
+            <a:schemeClr val="accent1"/>
+          </a:effectRef>
+          <a:fontRef idx="minor">
+            <a:schemeClr val="lt1"/>
+          </a:fontRef>
+        </p:style>
+        <p:txBody>
+          <a:bodyPr wrap="none" lIns="216000" bIns="0" rtlCol="0" anchor="ctr">
+            <a:normAutofit/>
+          </a:bodyPr>
+          <a:lstStyle/>
+          <a:p>
+            <a:pPr algn="ctr"/>
+            <a:r>
+              <a:rPr lang="en-US" sz="2000" b="1" dirty="0">
+                <a:solidFill>
+                  <a:schemeClr val="bg1"/>
+                </a:solidFill>
+                <a:latin typeface="Inter Medium" panose="02000503000000020004" pitchFamily="2" charset="0"/>
+                <a:ea typeface="Inter Medium" panose="02000503000000020004" pitchFamily="2" charset="0"/>
+              </a:rPr>
+              <a:t>1. Background</a:t>
+            </a:r>
+          </a:p>
+        </p:txBody>
+      </p:sp>
+      <p:sp>
+        <p:nvSpPr>
+          <p:cNvPr id="9" name="Rectangle: Rounded Corners 8">
+            <a:extLst>
+              <a:ext uri="{FF2B5EF4-FFF2-40B4-BE49-F238E27FC236}">
+                <a16:creationId xmlns:a16="http://schemas.microsoft.com/office/drawing/2014/main" id="{45AFEEB8-FB66-4B7A-40EB-5B7CCBA6CCA7}"/>
+              </a:ext>
+            </a:extLst>
+          </p:cNvPr>
+          <p:cNvSpPr/>
+          <p:nvPr/>
+        </p:nvSpPr>
+        <p:spPr>
+          <a:xfrm>
+            <a:off x="4672356" y="-626535"/>
+            <a:ext cx="1890000" cy="540001"/>
+          </a:xfrm>
+          <a:prstGeom prst="roundRect">
+            <a:avLst/>
+          </a:prstGeom>
+          <a:solidFill>
+            <a:schemeClr val="accent1">
+              <a:lumMod val="40000"/>
+              <a:lumOff val="60000"/>
+            </a:schemeClr>
+          </a:solidFill>
+          <a:ln w="28575">
+            <a:noFill/>
+          </a:ln>
+        </p:spPr>
+        <p:style>
+          <a:lnRef idx="2">
+            <a:schemeClr val="accent1">
+              <a:shade val="50000"/>
+            </a:schemeClr>
+          </a:lnRef>
+          <a:fillRef idx="1">
+            <a:schemeClr val="accent1"/>
+          </a:fillRef>
+          <a:effectRef idx="0">
+            <a:schemeClr val="accent1"/>
+          </a:effectRef>
+          <a:fontRef idx="minor">
+            <a:schemeClr val="lt1"/>
+          </a:fontRef>
+        </p:style>
+        <p:txBody>
+          <a:bodyPr wrap="none" lIns="0" tIns="0" rIns="0" bIns="0" rtlCol="0" anchor="ctr">
+            <a:normAutofit/>
+          </a:bodyPr>
+          <a:lstStyle/>
+          <a:p>
+            <a:pPr algn="ctr"/>
+            <a:r>
+              <a:rPr lang="en-US" sz="1600" dirty="0">
+                <a:solidFill>
+                  <a:schemeClr val="bg1"/>
+                </a:solidFill>
+                <a:latin typeface="Inter Medium" panose="02000503000000020004" pitchFamily="2" charset="0"/>
+                <a:ea typeface="Inter Medium" panose="02000503000000020004" pitchFamily="2" charset="0"/>
+              </a:rPr>
+              <a:t>2. Objectives</a:t>
+            </a:r>
+          </a:p>
+        </p:txBody>
+      </p:sp>
+      <p:sp>
+        <p:nvSpPr>
+          <p:cNvPr id="10" name="Rectangle: Rounded Corners 9">
+            <a:extLst>
+              <a:ext uri="{FF2B5EF4-FFF2-40B4-BE49-F238E27FC236}">
+                <a16:creationId xmlns:a16="http://schemas.microsoft.com/office/drawing/2014/main" id="{8941464C-7249-0A09-2704-80AEBE4C8C9B}"/>
+              </a:ext>
+            </a:extLst>
+          </p:cNvPr>
+          <p:cNvSpPr/>
+          <p:nvPr/>
+        </p:nvSpPr>
+        <p:spPr>
+          <a:xfrm>
+            <a:off x="6548904" y="-626534"/>
+            <a:ext cx="1890000" cy="540001"/>
+          </a:xfrm>
+          <a:prstGeom prst="roundRect">
+            <a:avLst/>
+          </a:prstGeom>
+          <a:solidFill>
+            <a:schemeClr val="accent1">
+              <a:lumMod val="40000"/>
+              <a:lumOff val="60000"/>
+            </a:schemeClr>
+          </a:solidFill>
+          <a:ln w="28575">
+            <a:noFill/>
+          </a:ln>
+        </p:spPr>
+        <p:style>
+          <a:lnRef idx="2">
+            <a:schemeClr val="accent1">
+              <a:shade val="50000"/>
+            </a:schemeClr>
+          </a:lnRef>
+          <a:fillRef idx="1">
+            <a:schemeClr val="accent1"/>
+          </a:fillRef>
+          <a:effectRef idx="0">
+            <a:schemeClr val="accent1"/>
+          </a:effectRef>
+          <a:fontRef idx="minor">
+            <a:schemeClr val="lt1"/>
+          </a:fontRef>
+        </p:style>
+        <p:txBody>
+          <a:bodyPr wrap="none" lIns="0" tIns="0" rIns="0" bIns="0" rtlCol="0" anchor="ctr">
+            <a:normAutofit/>
+          </a:bodyPr>
+          <a:lstStyle/>
+          <a:p>
+            <a:pPr algn="ctr"/>
+            <a:r>
+              <a:rPr lang="en-US" sz="1600" dirty="0">
+                <a:solidFill>
+                  <a:schemeClr val="bg1"/>
+                </a:solidFill>
+                <a:latin typeface="Inter Medium" panose="02000503000000020004" pitchFamily="2" charset="0"/>
+                <a:ea typeface="Inter Medium" panose="02000503000000020004" pitchFamily="2" charset="0"/>
+              </a:rPr>
+              <a:t>3. Progress</a:t>
+            </a:r>
+          </a:p>
+        </p:txBody>
+      </p:sp>
+      <p:sp>
+        <p:nvSpPr>
+          <p:cNvPr id="11" name="Rectangle: Rounded Corners 10">
+            <a:extLst>
+              <a:ext uri="{FF2B5EF4-FFF2-40B4-BE49-F238E27FC236}">
+                <a16:creationId xmlns:a16="http://schemas.microsoft.com/office/drawing/2014/main" id="{A84B2402-EC28-E834-E5BB-5E4281B410E2}"/>
+              </a:ext>
+            </a:extLst>
+          </p:cNvPr>
+          <p:cNvSpPr/>
+          <p:nvPr/>
+        </p:nvSpPr>
+        <p:spPr>
+          <a:xfrm>
+            <a:off x="8425452" y="-626534"/>
+            <a:ext cx="1890000" cy="540001"/>
+          </a:xfrm>
+          <a:prstGeom prst="roundRect">
+            <a:avLst/>
+          </a:prstGeom>
+          <a:solidFill>
+            <a:schemeClr val="accent1">
+              <a:lumMod val="40000"/>
+              <a:lumOff val="60000"/>
+            </a:schemeClr>
+          </a:solidFill>
+          <a:ln w="28575">
+            <a:noFill/>
+          </a:ln>
+        </p:spPr>
+        <p:style>
+          <a:lnRef idx="2">
+            <a:schemeClr val="accent1">
+              <a:shade val="50000"/>
+            </a:schemeClr>
+          </a:lnRef>
+          <a:fillRef idx="1">
+            <a:schemeClr val="accent1"/>
+          </a:fillRef>
+          <a:effectRef idx="0">
+            <a:schemeClr val="accent1"/>
+          </a:effectRef>
+          <a:fontRef idx="minor">
+            <a:schemeClr val="lt1"/>
+          </a:fontRef>
+        </p:style>
+        <p:txBody>
+          <a:bodyPr wrap="none" lIns="0" tIns="0" rIns="0" bIns="0" rtlCol="0" anchor="ctr">
+            <a:normAutofit/>
+          </a:bodyPr>
+          <a:lstStyle/>
+          <a:p>
+            <a:pPr algn="ctr"/>
+            <a:r>
+              <a:rPr lang="en-US" sz="1600" dirty="0">
+                <a:solidFill>
+                  <a:schemeClr val="bg1"/>
+                </a:solidFill>
+                <a:latin typeface="Inter Medium" panose="02000503000000020004" pitchFamily="2" charset="0"/>
+                <a:ea typeface="Inter Medium" panose="02000503000000020004" pitchFamily="2" charset="0"/>
+              </a:rPr>
+              <a:t>4. Plan</a:t>
+            </a:r>
+          </a:p>
+        </p:txBody>
+      </p:sp>
+      <p:sp>
+        <p:nvSpPr>
+          <p:cNvPr id="12" name="Rectangle: Rounded Corners 11">
+            <a:extLst>
+              <a:ext uri="{FF2B5EF4-FFF2-40B4-BE49-F238E27FC236}">
+                <a16:creationId xmlns:a16="http://schemas.microsoft.com/office/drawing/2014/main" id="{0A464FDF-3AE6-4DF4-F9F9-CAA102DD54A1}"/>
+              </a:ext>
+            </a:extLst>
+          </p:cNvPr>
+          <p:cNvSpPr/>
+          <p:nvPr/>
+        </p:nvSpPr>
+        <p:spPr>
+          <a:xfrm>
+            <a:off x="10302000" y="-626536"/>
+            <a:ext cx="1890000" cy="540001"/>
+          </a:xfrm>
+          <a:prstGeom prst="roundRect">
+            <a:avLst/>
+          </a:prstGeom>
+          <a:solidFill>
+            <a:schemeClr val="accent1">
+              <a:lumMod val="40000"/>
+              <a:lumOff val="60000"/>
+            </a:schemeClr>
+          </a:solidFill>
+          <a:ln w="28575">
+            <a:noFill/>
+          </a:ln>
+        </p:spPr>
+        <p:style>
+          <a:lnRef idx="2">
+            <a:schemeClr val="accent1">
+              <a:shade val="50000"/>
+            </a:schemeClr>
+          </a:lnRef>
+          <a:fillRef idx="1">
+            <a:schemeClr val="accent1"/>
+          </a:fillRef>
+          <a:effectRef idx="0">
+            <a:schemeClr val="accent1"/>
+          </a:effectRef>
+          <a:fontRef idx="minor">
+            <a:schemeClr val="lt1"/>
+          </a:fontRef>
+        </p:style>
+        <p:txBody>
+          <a:bodyPr wrap="none" lIns="0" tIns="0" rIns="0" bIns="0" rtlCol="0" anchor="ctr">
+            <a:normAutofit/>
+          </a:bodyPr>
+          <a:lstStyle/>
+          <a:p>
+            <a:pPr algn="ctr"/>
+            <a:r>
+              <a:rPr lang="en-US" sz="1600" dirty="0">
+                <a:solidFill>
+                  <a:schemeClr val="bg1"/>
+                </a:solidFill>
+                <a:latin typeface="Inter Medium" panose="02000503000000020004" pitchFamily="2" charset="0"/>
+                <a:ea typeface="Inter Medium" panose="02000503000000020004" pitchFamily="2" charset="0"/>
+              </a:rPr>
+              <a:t>5. Summary</a:t>
+            </a:r>
+          </a:p>
+        </p:txBody>
+      </p:sp>
     </p:spTree>
     <p:extLst>
       <p:ext uri="{BB962C8B-B14F-4D97-AF65-F5344CB8AC3E}">
@@ -44117,9 +46235,14 @@
   <p:clrMapOvr>
     <a:masterClrMapping/>
   </p:clrMapOvr>
-  <p:transition>
-    <p:fade/>
-  </p:transition>
+  <mc:AlternateContent xmlns:mc="http://schemas.openxmlformats.org/markup-compatibility/2006">
+    <mc:Choice xmlns:p14="http://schemas.microsoft.com/office/powerpoint/2010/main" Requires="p14">
+      <p:transition p14:dur="0"/>
+    </mc:Choice>
+    <mc:Fallback>
+      <p:transition/>
+    </mc:Fallback>
+  </mc:AlternateContent>
 </p:sld>
 </file>
 
@@ -44876,13 +46999,13 @@
         </p:nvSpPr>
         <p:spPr>
           <a:xfrm>
-            <a:off x="0" y="0"/>
-            <a:ext cx="4682067" cy="540000"/>
+            <a:off x="-5572" y="0"/>
+            <a:ext cx="4680000" cy="540000"/>
           </a:xfrm>
           <a:prstGeom prst="roundRect">
             <a:avLst/>
           </a:prstGeom>
-          <a:ln>
+          <a:ln w="28575">
             <a:noFill/>
           </a:ln>
         </p:spPr>
@@ -44910,7 +47033,7 @@
           <a:p>
             <a:pPr algn="ctr"/>
             <a:r>
-              <a:rPr lang="en-US" sz="1600" dirty="0">
+              <a:rPr lang="en-US" sz="2000" b="1" dirty="0">
                 <a:solidFill>
                   <a:schemeClr val="bg1"/>
                 </a:solidFill>
@@ -44936,8 +47059,8 @@
         </p:nvSpPr>
         <p:spPr>
           <a:xfrm>
-            <a:off x="4680425" y="-1"/>
-            <a:ext cx="1872000" cy="540001"/>
+            <a:off x="4672356" y="-2"/>
+            <a:ext cx="1890000" cy="540001"/>
           </a:xfrm>
           <a:prstGeom prst="roundRect">
             <a:avLst/>
@@ -44948,13 +47071,8 @@
               <a:lumOff val="60000"/>
             </a:schemeClr>
           </a:solidFill>
-          <a:ln>
-            <a:solidFill>
-              <a:schemeClr val="tx2">
-                <a:lumMod val="60000"/>
-                <a:lumOff val="40000"/>
-              </a:schemeClr>
-            </a:solidFill>
+          <a:ln w="28575">
+            <a:noFill/>
           </a:ln>
         </p:spPr>
         <p:style>
@@ -45007,8 +47125,8 @@
         </p:nvSpPr>
         <p:spPr>
           <a:xfrm>
-            <a:off x="6560283" y="-1"/>
-            <a:ext cx="1872000" cy="540001"/>
+            <a:off x="6548904" y="-1"/>
+            <a:ext cx="1890000" cy="540001"/>
           </a:xfrm>
           <a:prstGeom prst="roundRect">
             <a:avLst/>
@@ -45019,13 +47137,8 @@
               <a:lumOff val="60000"/>
             </a:schemeClr>
           </a:solidFill>
-          <a:ln>
-            <a:solidFill>
-              <a:schemeClr val="tx2">
-                <a:lumMod val="60000"/>
-                <a:lumOff val="40000"/>
-              </a:schemeClr>
-            </a:solidFill>
+          <a:ln w="28575">
+            <a:noFill/>
           </a:ln>
         </p:spPr>
         <p:style>
@@ -45078,8 +47191,8 @@
         </p:nvSpPr>
         <p:spPr>
           <a:xfrm>
-            <a:off x="8440141" y="-1"/>
-            <a:ext cx="1872000" cy="540001"/>
+            <a:off x="8425452" y="-1"/>
+            <a:ext cx="1890000" cy="540001"/>
           </a:xfrm>
           <a:prstGeom prst="roundRect">
             <a:avLst/>
@@ -45090,13 +47203,8 @@
               <a:lumOff val="60000"/>
             </a:schemeClr>
           </a:solidFill>
-          <a:ln>
-            <a:solidFill>
-              <a:schemeClr val="tx2">
-                <a:lumMod val="60000"/>
-                <a:lumOff val="40000"/>
-              </a:schemeClr>
-            </a:solidFill>
+          <a:ln w="28575">
+            <a:noFill/>
           </a:ln>
         </p:spPr>
         <p:style>
@@ -45149,8 +47257,8 @@
         </p:nvSpPr>
         <p:spPr>
           <a:xfrm>
-            <a:off x="10320000" y="-1"/>
-            <a:ext cx="1872000" cy="540001"/>
+            <a:off x="10302000" y="-3"/>
+            <a:ext cx="1890000" cy="540001"/>
           </a:xfrm>
           <a:prstGeom prst="roundRect">
             <a:avLst/>
@@ -45161,13 +47269,8 @@
               <a:lumOff val="60000"/>
             </a:schemeClr>
           </a:solidFill>
-          <a:ln>
-            <a:solidFill>
-              <a:schemeClr val="tx2">
-                <a:lumMod val="60000"/>
-                <a:lumOff val="40000"/>
-              </a:schemeClr>
-            </a:solidFill>
+          <a:ln w="28575">
+            <a:noFill/>
           </a:ln>
         </p:spPr>
         <p:style>
@@ -45206,6 +47309,356 @@
           </a:p>
         </p:txBody>
       </p:sp>
+      <p:sp>
+        <p:nvSpPr>
+          <p:cNvPr id="25" name="Title 1">
+            <a:extLst>
+              <a:ext uri="{FF2B5EF4-FFF2-40B4-BE49-F238E27FC236}">
+                <a16:creationId xmlns:a16="http://schemas.microsoft.com/office/drawing/2014/main" id="{514BC2A7-BF21-7C2A-F0E0-7C7CD3BA577D}"/>
+              </a:ext>
+            </a:extLst>
+          </p:cNvPr>
+          <p:cNvSpPr>
+            <a:spLocks noGrp="1"/>
+          </p:cNvSpPr>
+          <p:nvPr>
+            <p:ph type="title"/>
+          </p:nvPr>
+        </p:nvSpPr>
+        <p:spPr>
+          <a:xfrm>
+            <a:off x="-2505986" y="327819"/>
+            <a:ext cx="5163243" cy="3101181"/>
+          </a:xfrm>
+        </p:spPr>
+        <p:txBody>
+          <a:bodyPr/>
+          <a:lstStyle/>
+          <a:p>
+            <a:r>
+              <a:rPr lang="en-US" dirty="0"/>
+              <a:t>Agenda</a:t>
+            </a:r>
+            <a:endParaRPr lang="en-GB" dirty="0"/>
+          </a:p>
+        </p:txBody>
+      </p:sp>
+      <p:graphicFrame>
+        <p:nvGraphicFramePr>
+          <p:cNvPr id="26" name="Content Placeholder 3">
+            <a:extLst>
+              <a:ext uri="{FF2B5EF4-FFF2-40B4-BE49-F238E27FC236}">
+                <a16:creationId xmlns:a16="http://schemas.microsoft.com/office/drawing/2014/main" id="{A525F7C1-3E6A-6215-82BE-DC3E114AA805}"/>
+              </a:ext>
+            </a:extLst>
+          </p:cNvPr>
+          <p:cNvGraphicFramePr>
+            <a:graphicFrameLocks noGrp="1"/>
+          </p:cNvGraphicFramePr>
+          <p:nvPr>
+            <p:ph sz="quarter" idx="13"/>
+            <p:extLst>
+              <p:ext uri="{D42A27DB-BD31-4B8C-83A1-F6EECF244321}">
+                <p14:modId xmlns:p14="http://schemas.microsoft.com/office/powerpoint/2010/main" val="3483975427"/>
+              </p:ext>
+            </p:extLst>
+          </p:nvPr>
+        </p:nvGraphicFramePr>
+        <p:xfrm>
+          <a:off x="12400280" y="328613"/>
+          <a:ext cx="5776912" cy="1228090"/>
+        </p:xfrm>
+        <a:graphic>
+          <a:graphicData uri="http://schemas.openxmlformats.org/drawingml/2006/table">
+            <a:tbl>
+              <a:tblPr>
+                <a:tableStyleId>{2D5ABB26-0587-4C30-8999-92F81FD0307C}</a:tableStyleId>
+              </a:tblPr>
+              <a:tblGrid>
+                <a:gridCol w="613797">
+                  <a:extLst>
+                    <a:ext uri="{9D8B030D-6E8A-4147-A177-3AD203B41FA5}">
+                      <a16:colId xmlns:a16="http://schemas.microsoft.com/office/drawing/2014/main" val="2312058624"/>
+                    </a:ext>
+                  </a:extLst>
+                </a:gridCol>
+                <a:gridCol w="5163115">
+                  <a:extLst>
+                    <a:ext uri="{9D8B030D-6E8A-4147-A177-3AD203B41FA5}">
+                      <a16:colId xmlns:a16="http://schemas.microsoft.com/office/drawing/2014/main" val="2529335587"/>
+                    </a:ext>
+                  </a:extLst>
+                </a:gridCol>
+              </a:tblGrid>
+              <a:tr h="240665">
+                <a:tc>
+                  <a:txBody>
+                    <a:bodyPr/>
+                    <a:lstStyle/>
+                    <a:p>
+                      <a:pPr>
+                        <a:lnSpc>
+                          <a:spcPct val="105000"/>
+                        </a:lnSpc>
+                      </a:pPr>
+                      <a:r>
+                        <a:rPr lang="en-US" sz="1600" b="1" dirty="0">
+                          <a:solidFill>
+                            <a:srgbClr val="0000CD"/>
+                          </a:solidFill>
+                        </a:rPr>
+                        <a:t>1</a:t>
+                      </a:r>
+                    </a:p>
+                  </a:txBody>
+                  <a:tcPr marL="0" marR="0" marT="0" marB="0"/>
+                </a:tc>
+                <a:tc>
+                  <a:txBody>
+                    <a:bodyPr/>
+                    <a:lstStyle/>
+                    <a:p>
+                      <a:pPr>
+                        <a:lnSpc>
+                          <a:spcPct val="105000"/>
+                        </a:lnSpc>
+                      </a:pPr>
+                      <a:r>
+                        <a:rPr lang="en-US" sz="1600" dirty="0">
+                          <a:solidFill>
+                            <a:srgbClr val="0000CD"/>
+                          </a:solidFill>
+                          <a:latin typeface="Inter Medium" panose="02000503000000020004" pitchFamily="2" charset="0"/>
+                          <a:ea typeface="Inter Medium" panose="02000503000000020004" pitchFamily="2" charset="0"/>
+                        </a:rPr>
+                        <a:t>Background</a:t>
+                      </a:r>
+                    </a:p>
+                  </a:txBody>
+                  <a:tcPr marL="0" marR="0" marT="0" marB="0"/>
+                </a:tc>
+                <a:extLst>
+                  <a:ext uri="{0D108BD9-81ED-4DB2-BD59-A6C34878D82A}">
+                    <a16:rowId xmlns:a16="http://schemas.microsoft.com/office/drawing/2014/main" val="2813600567"/>
+                  </a:ext>
+                </a:extLst>
+              </a:tr>
+              <a:tr h="240665">
+                <a:tc>
+                  <a:txBody>
+                    <a:bodyPr/>
+                    <a:lstStyle/>
+                    <a:p>
+                      <a:pPr>
+                        <a:lnSpc>
+                          <a:spcPct val="105000"/>
+                        </a:lnSpc>
+                      </a:pPr>
+                      <a:r>
+                        <a:rPr lang="en-US" sz="1600" b="1" dirty="0">
+                          <a:solidFill>
+                            <a:srgbClr val="0000CD"/>
+                          </a:solidFill>
+                        </a:rPr>
+                        <a:t>2</a:t>
+                      </a:r>
+                    </a:p>
+                  </a:txBody>
+                  <a:tcPr marL="0" marR="0" marT="0" marB="0"/>
+                </a:tc>
+                <a:tc>
+                  <a:txBody>
+                    <a:bodyPr/>
+                    <a:lstStyle/>
+                    <a:p>
+                      <a:pPr>
+                        <a:lnSpc>
+                          <a:spcPct val="105000"/>
+                        </a:lnSpc>
+                      </a:pPr>
+                      <a:r>
+                        <a:rPr lang="en-US" sz="1600" dirty="0">
+                          <a:solidFill>
+                            <a:srgbClr val="0000CD"/>
+                          </a:solidFill>
+                          <a:latin typeface="Inter Medium" panose="02000503000000020004" pitchFamily="2" charset="0"/>
+                          <a:ea typeface="Inter Medium" panose="02000503000000020004" pitchFamily="2" charset="0"/>
+                        </a:rPr>
+                        <a:t>Project Aims &amp; Objectives</a:t>
+                      </a:r>
+                    </a:p>
+                  </a:txBody>
+                  <a:tcPr marL="0" marR="0" marT="0" marB="0"/>
+                </a:tc>
+                <a:extLst>
+                  <a:ext uri="{0D108BD9-81ED-4DB2-BD59-A6C34878D82A}">
+                    <a16:rowId xmlns:a16="http://schemas.microsoft.com/office/drawing/2014/main" val="2377395039"/>
+                  </a:ext>
+                </a:extLst>
+              </a:tr>
+              <a:tr h="240665">
+                <a:tc>
+                  <a:txBody>
+                    <a:bodyPr/>
+                    <a:lstStyle/>
+                    <a:p>
+                      <a:pPr>
+                        <a:lnSpc>
+                          <a:spcPct val="105000"/>
+                        </a:lnSpc>
+                      </a:pPr>
+                      <a:r>
+                        <a:rPr lang="en-US" sz="1600" b="1" dirty="0">
+                          <a:solidFill>
+                            <a:srgbClr val="0000CD"/>
+                          </a:solidFill>
+                        </a:rPr>
+                        <a:t>3</a:t>
+                      </a:r>
+                    </a:p>
+                  </a:txBody>
+                  <a:tcPr marL="0" marR="0" marT="0" marB="0"/>
+                </a:tc>
+                <a:tc>
+                  <a:txBody>
+                    <a:bodyPr/>
+                    <a:lstStyle/>
+                    <a:p>
+                      <a:pPr>
+                        <a:lnSpc>
+                          <a:spcPct val="105000"/>
+                        </a:lnSpc>
+                      </a:pPr>
+                      <a:r>
+                        <a:rPr lang="en-US" sz="1600" dirty="0">
+                          <a:solidFill>
+                            <a:srgbClr val="0000CD"/>
+                          </a:solidFill>
+                          <a:latin typeface="Inter Medium" panose="02000503000000020004" pitchFamily="2" charset="0"/>
+                          <a:ea typeface="Inter Medium" panose="02000503000000020004" pitchFamily="2" charset="0"/>
+                        </a:rPr>
+                        <a:t>Progress to Date</a:t>
+                      </a:r>
+                    </a:p>
+                  </a:txBody>
+                  <a:tcPr marL="0" marR="0" marT="0" marB="0"/>
+                </a:tc>
+                <a:extLst>
+                  <a:ext uri="{0D108BD9-81ED-4DB2-BD59-A6C34878D82A}">
+                    <a16:rowId xmlns:a16="http://schemas.microsoft.com/office/drawing/2014/main" val="3619643445"/>
+                  </a:ext>
+                </a:extLst>
+              </a:tr>
+              <a:tr h="240665">
+                <a:tc>
+                  <a:txBody>
+                    <a:bodyPr/>
+                    <a:lstStyle/>
+                    <a:p>
+                      <a:pPr>
+                        <a:lnSpc>
+                          <a:spcPct val="105000"/>
+                        </a:lnSpc>
+                      </a:pPr>
+                      <a:r>
+                        <a:rPr lang="en-US" sz="1600" b="1" dirty="0">
+                          <a:solidFill>
+                            <a:srgbClr val="0000CD"/>
+                          </a:solidFill>
+                        </a:rPr>
+                        <a:t>4</a:t>
+                      </a:r>
+                    </a:p>
+                  </a:txBody>
+                  <a:tcPr marL="0" marR="0" marT="0" marB="0"/>
+                </a:tc>
+                <a:tc>
+                  <a:txBody>
+                    <a:bodyPr/>
+                    <a:lstStyle/>
+                    <a:p>
+                      <a:pPr>
+                        <a:lnSpc>
+                          <a:spcPct val="105000"/>
+                        </a:lnSpc>
+                      </a:pPr>
+                      <a:r>
+                        <a:rPr lang="en-US" sz="1600" dirty="0">
+                          <a:solidFill>
+                            <a:srgbClr val="0000CD"/>
+                          </a:solidFill>
+                          <a:latin typeface="Inter Medium" panose="02000503000000020004" pitchFamily="2" charset="0"/>
+                          <a:ea typeface="Inter Medium" panose="02000503000000020004" pitchFamily="2" charset="0"/>
+                        </a:rPr>
+                        <a:t>Plan for Remainder</a:t>
+                      </a:r>
+                    </a:p>
+                  </a:txBody>
+                  <a:tcPr marL="0" marR="0" marT="0" marB="0"/>
+                </a:tc>
+                <a:extLst>
+                  <a:ext uri="{0D108BD9-81ED-4DB2-BD59-A6C34878D82A}">
+                    <a16:rowId xmlns:a16="http://schemas.microsoft.com/office/drawing/2014/main" val="2813601940"/>
+                  </a:ext>
+                </a:extLst>
+              </a:tr>
+              <a:tr h="240665">
+                <a:tc>
+                  <a:txBody>
+                    <a:bodyPr/>
+                    <a:lstStyle/>
+                    <a:p>
+                      <a:pPr>
+                        <a:lnSpc>
+                          <a:spcPct val="105000"/>
+                        </a:lnSpc>
+                      </a:pPr>
+                      <a:r>
+                        <a:rPr lang="en-US" sz="1600" b="1" dirty="0">
+                          <a:solidFill>
+                            <a:srgbClr val="0000CD"/>
+                          </a:solidFill>
+                        </a:rPr>
+                        <a:t>5</a:t>
+                      </a:r>
+                    </a:p>
+                  </a:txBody>
+                  <a:tcPr marL="0" marR="0" marT="0" marB="0"/>
+                </a:tc>
+                <a:tc>
+                  <a:txBody>
+                    <a:bodyPr/>
+                    <a:lstStyle/>
+                    <a:p>
+                      <a:pPr>
+                        <a:lnSpc>
+                          <a:spcPct val="105000"/>
+                        </a:lnSpc>
+                      </a:pPr>
+                      <a:r>
+                        <a:rPr lang="en-US" sz="1600" dirty="0">
+                          <a:solidFill>
+                            <a:srgbClr val="0000CD"/>
+                          </a:solidFill>
+                          <a:latin typeface="Inter Medium" panose="02000503000000020004" pitchFamily="2" charset="0"/>
+                          <a:ea typeface="Inter Medium" panose="02000503000000020004" pitchFamily="2" charset="0"/>
+                        </a:rPr>
+                        <a:t>Summary &amp; Conclusion</a:t>
+                      </a:r>
+                    </a:p>
+                  </a:txBody>
+                  <a:tcPr marL="0" marR="0" marT="0" marB="0"/>
+                </a:tc>
+                <a:extLst>
+                  <a:ext uri="{0D108BD9-81ED-4DB2-BD59-A6C34878D82A}">
+                    <a16:rowId xmlns:a16="http://schemas.microsoft.com/office/drawing/2014/main" val="2337709630"/>
+                  </a:ext>
+                </a:extLst>
+              </a:tr>
+            </a:tbl>
+          </a:graphicData>
+        </a:graphic>
+      </p:graphicFrame>
     </p:spTree>
     <p:extLst>
       <p:ext uri="{BB962C8B-B14F-4D97-AF65-F5344CB8AC3E}">
@@ -45216,9 +47669,18 @@
   <p:clrMapOvr>
     <a:masterClrMapping/>
   </p:clrMapOvr>
-  <p:transition>
-    <p:fade/>
-  </p:transition>
+  <mc:AlternateContent xmlns:mc="http://schemas.openxmlformats.org/markup-compatibility/2006">
+    <mc:Choice xmlns:p159="http://schemas.microsoft.com/office/powerpoint/2015/09/main" Requires="p159">
+      <p:transition xmlns:p14="http://schemas.microsoft.com/office/powerpoint/2010/main" spd="slow" p14:dur="2000">
+        <p159:morph option="byObject"/>
+      </p:transition>
+    </mc:Choice>
+    <mc:Fallback>
+      <p:transition spd="slow">
+        <p:fade/>
+      </p:transition>
+    </mc:Fallback>
+  </mc:AlternateContent>
 </p:sld>
 </file>
 
@@ -45351,8 +47813,8 @@
         </p:nvSpPr>
         <p:spPr>
           <a:xfrm>
-            <a:off x="0" y="0"/>
-            <a:ext cx="1872000" cy="540000"/>
+            <a:off x="-5071" y="0"/>
+            <a:ext cx="1890000" cy="540000"/>
           </a:xfrm>
           <a:prstGeom prst="roundRect">
             <a:avLst/>
@@ -45363,13 +47825,8 @@
               <a:lumOff val="60000"/>
             </a:schemeClr>
           </a:solidFill>
-          <a:ln>
-            <a:solidFill>
-              <a:schemeClr val="tx2">
-                <a:lumMod val="60000"/>
-                <a:lumOff val="40000"/>
-              </a:schemeClr>
-            </a:solidFill>
+          <a:ln w="28575">
+            <a:noFill/>
           </a:ln>
         </p:spPr>
         <p:style>
@@ -45422,8 +47879,8 @@
         </p:nvSpPr>
         <p:spPr>
           <a:xfrm>
-            <a:off x="1879858" y="-2"/>
-            <a:ext cx="4683600" cy="540001"/>
+            <a:off x="1874197" y="-2"/>
+            <a:ext cx="4680000" cy="540000"/>
           </a:xfrm>
           <a:prstGeom prst="roundRect">
             <a:avLst/>
@@ -45431,13 +47888,8 @@
           <a:solidFill>
             <a:schemeClr val="accent1"/>
           </a:solidFill>
-          <a:ln>
-            <a:solidFill>
-              <a:schemeClr val="tx2">
-                <a:lumMod val="60000"/>
-                <a:lumOff val="40000"/>
-              </a:schemeClr>
-            </a:solidFill>
+          <a:ln w="28575">
+            <a:noFill/>
           </a:ln>
         </p:spPr>
         <p:style>
@@ -45464,7 +47916,7 @@
           <a:p>
             <a:pPr algn="ctr"/>
             <a:r>
-              <a:rPr lang="en-US" sz="1600" dirty="0">
+              <a:rPr lang="en-US" sz="2000" b="1" dirty="0">
                 <a:solidFill>
                   <a:schemeClr val="bg1"/>
                 </a:solidFill>
@@ -45490,8 +47942,8 @@
         </p:nvSpPr>
         <p:spPr>
           <a:xfrm>
-            <a:off x="6560283" y="-1"/>
-            <a:ext cx="1872000" cy="540001"/>
+            <a:off x="6543465" y="-1"/>
+            <a:ext cx="1890000" cy="540000"/>
           </a:xfrm>
           <a:prstGeom prst="roundRect">
             <a:avLst/>
@@ -45502,13 +47954,8 @@
               <a:lumOff val="60000"/>
             </a:schemeClr>
           </a:solidFill>
-          <a:ln>
-            <a:solidFill>
-              <a:schemeClr val="tx2">
-                <a:lumMod val="60000"/>
-                <a:lumOff val="40000"/>
-              </a:schemeClr>
-            </a:solidFill>
+          <a:ln w="28575">
+            <a:noFill/>
           </a:ln>
         </p:spPr>
         <p:style>
@@ -45561,8 +48008,8 @@
         </p:nvSpPr>
         <p:spPr>
           <a:xfrm>
-            <a:off x="8440141" y="-1"/>
-            <a:ext cx="1872000" cy="540001"/>
+            <a:off x="8422733" y="-1"/>
+            <a:ext cx="1890000" cy="540000"/>
           </a:xfrm>
           <a:prstGeom prst="roundRect">
             <a:avLst/>
@@ -45573,13 +48020,8 @@
               <a:lumOff val="60000"/>
             </a:schemeClr>
           </a:solidFill>
-          <a:ln>
-            <a:solidFill>
-              <a:schemeClr val="tx2">
-                <a:lumMod val="60000"/>
-                <a:lumOff val="40000"/>
-              </a:schemeClr>
-            </a:solidFill>
+          <a:ln w="28575">
+            <a:noFill/>
           </a:ln>
         </p:spPr>
         <p:style>
@@ -45632,8 +48074,8 @@
         </p:nvSpPr>
         <p:spPr>
           <a:xfrm>
-            <a:off x="10320000" y="-1"/>
-            <a:ext cx="1872000" cy="540001"/>
+            <a:off x="10302000" y="-3"/>
+            <a:ext cx="1890000" cy="540000"/>
           </a:xfrm>
           <a:prstGeom prst="roundRect">
             <a:avLst/>
@@ -45644,13 +48086,8 @@
               <a:lumOff val="60000"/>
             </a:schemeClr>
           </a:solidFill>
-          <a:ln>
-            <a:solidFill>
-              <a:schemeClr val="tx2">
-                <a:lumMod val="60000"/>
-                <a:lumOff val="40000"/>
-              </a:schemeClr>
-            </a:solidFill>
+          <a:ln w="28575">
+            <a:noFill/>
           </a:ln>
         </p:spPr>
         <p:style>
@@ -45699,9 +48136,18 @@
   <p:clrMapOvr>
     <a:masterClrMapping/>
   </p:clrMapOvr>
-  <p:transition>
-    <p:fade/>
-  </p:transition>
+  <mc:AlternateContent xmlns:mc="http://schemas.openxmlformats.org/markup-compatibility/2006">
+    <mc:Choice xmlns:p159="http://schemas.microsoft.com/office/powerpoint/2015/09/main" Requires="p159">
+      <p:transition xmlns:p14="http://schemas.microsoft.com/office/powerpoint/2010/main" spd="slow" p14:dur="2000">
+        <p159:morph option="byObject"/>
+      </p:transition>
+    </mc:Choice>
+    <mc:Fallback>
+      <p:transition spd="slow">
+        <p:fade/>
+      </p:transition>
+    </mc:Fallback>
+  </mc:AlternateContent>
 </p:sld>
 </file>
 
@@ -45834,8 +48280,8 @@
         </p:nvSpPr>
         <p:spPr>
           <a:xfrm>
-            <a:off x="0" y="0"/>
-            <a:ext cx="1872000" cy="540000"/>
+            <a:off x="-6450" y="0"/>
+            <a:ext cx="1890000" cy="540000"/>
           </a:xfrm>
           <a:prstGeom prst="roundRect">
             <a:avLst/>
@@ -45846,13 +48292,8 @@
               <a:lumOff val="60000"/>
             </a:schemeClr>
           </a:solidFill>
-          <a:ln>
-            <a:solidFill>
-              <a:schemeClr val="tx2">
-                <a:lumMod val="60000"/>
-                <a:lumOff val="40000"/>
-              </a:schemeClr>
-            </a:solidFill>
+          <a:ln w="28575">
+            <a:noFill/>
           </a:ln>
         </p:spPr>
         <p:style>
@@ -45906,7 +48347,7 @@
         <p:spPr>
           <a:xfrm>
             <a:off x="1877100" y="-2"/>
-            <a:ext cx="1872000" cy="540001"/>
+            <a:ext cx="1890000" cy="540000"/>
           </a:xfrm>
           <a:prstGeom prst="roundRect">
             <a:avLst/>
@@ -45917,13 +48358,8 @@
               <a:lumOff val="60000"/>
             </a:schemeClr>
           </a:solidFill>
-          <a:ln>
-            <a:solidFill>
-              <a:schemeClr val="tx2">
-                <a:lumMod val="60000"/>
-                <a:lumOff val="40000"/>
-              </a:schemeClr>
-            </a:solidFill>
+          <a:ln w="28575">
+            <a:noFill/>
           </a:ln>
         </p:spPr>
         <p:style>
@@ -45976,8 +48412,8 @@
         </p:nvSpPr>
         <p:spPr>
           <a:xfrm>
-            <a:off x="3754200" y="-1"/>
-            <a:ext cx="4683600" cy="540001"/>
+            <a:off x="3755400" y="-1"/>
+            <a:ext cx="4680000" cy="540000"/>
           </a:xfrm>
           <a:prstGeom prst="roundRect">
             <a:avLst/>
@@ -45985,13 +48421,8 @@
           <a:solidFill>
             <a:schemeClr val="accent1"/>
           </a:solidFill>
-          <a:ln>
-            <a:solidFill>
-              <a:schemeClr val="tx2">
-                <a:lumMod val="60000"/>
-                <a:lumOff val="40000"/>
-              </a:schemeClr>
-            </a:solidFill>
+          <a:ln w="28575">
+            <a:noFill/>
           </a:ln>
         </p:spPr>
         <p:style>
@@ -46018,7 +48449,7 @@
           <a:p>
             <a:pPr algn="ctr"/>
             <a:r>
-              <a:rPr lang="en-US" sz="1600" dirty="0">
+              <a:rPr lang="en-US" sz="2000" b="1" dirty="0">
                 <a:solidFill>
                   <a:schemeClr val="bg1"/>
                 </a:solidFill>
@@ -46044,8 +48475,8 @@
         </p:nvSpPr>
         <p:spPr>
           <a:xfrm>
-            <a:off x="8442900" y="-1"/>
-            <a:ext cx="1872000" cy="540001"/>
+            <a:off x="8423700" y="-1"/>
+            <a:ext cx="1890000" cy="540000"/>
           </a:xfrm>
           <a:prstGeom prst="roundRect">
             <a:avLst/>
@@ -46056,13 +48487,8 @@
               <a:lumOff val="60000"/>
             </a:schemeClr>
           </a:solidFill>
-          <a:ln>
-            <a:solidFill>
-              <a:schemeClr val="tx2">
-                <a:lumMod val="60000"/>
-                <a:lumOff val="40000"/>
-              </a:schemeClr>
-            </a:solidFill>
+          <a:ln w="28575">
+            <a:noFill/>
           </a:ln>
         </p:spPr>
         <p:style>
@@ -46115,8 +48541,8 @@
         </p:nvSpPr>
         <p:spPr>
           <a:xfrm>
-            <a:off x="10320000" y="-1"/>
-            <a:ext cx="1872000" cy="540001"/>
+            <a:off x="10302000" y="-2"/>
+            <a:ext cx="1890000" cy="540000"/>
           </a:xfrm>
           <a:prstGeom prst="roundRect">
             <a:avLst/>
@@ -46127,13 +48553,8 @@
               <a:lumOff val="60000"/>
             </a:schemeClr>
           </a:solidFill>
-          <a:ln>
-            <a:solidFill>
-              <a:schemeClr val="tx2">
-                <a:lumMod val="60000"/>
-                <a:lumOff val="40000"/>
-              </a:schemeClr>
-            </a:solidFill>
+          <a:ln w="28575">
+            <a:noFill/>
           </a:ln>
         </p:spPr>
         <p:style>
@@ -46182,9 +48603,18 @@
   <p:clrMapOvr>
     <a:masterClrMapping/>
   </p:clrMapOvr>
-  <p:transition>
-    <p:fade/>
-  </p:transition>
+  <mc:AlternateContent xmlns:mc="http://schemas.openxmlformats.org/markup-compatibility/2006">
+    <mc:Choice xmlns:p159="http://schemas.microsoft.com/office/powerpoint/2015/09/main" Requires="p159">
+      <p:transition xmlns:p14="http://schemas.microsoft.com/office/powerpoint/2010/main" spd="slow" p14:dur="2000">
+        <p159:morph option="byObject"/>
+      </p:transition>
+    </mc:Choice>
+    <mc:Fallback>
+      <p:transition spd="slow">
+        <p:fade/>
+      </p:transition>
+    </mc:Fallback>
+  </mc:AlternateContent>
 </p:sld>
 </file>
 
@@ -46317,8 +48747,8 @@
         </p:nvSpPr>
         <p:spPr>
           <a:xfrm>
-            <a:off x="0" y="0"/>
-            <a:ext cx="1872000" cy="540000"/>
+            <a:off x="-17250" y="0"/>
+            <a:ext cx="1890000" cy="540000"/>
           </a:xfrm>
           <a:prstGeom prst="roundRect">
             <a:avLst/>
@@ -46329,13 +48759,8 @@
               <a:lumOff val="60000"/>
             </a:schemeClr>
           </a:solidFill>
-          <a:ln>
-            <a:solidFill>
-              <a:schemeClr val="tx2">
-                <a:lumMod val="60000"/>
-                <a:lumOff val="40000"/>
-              </a:schemeClr>
-            </a:solidFill>
+          <a:ln w="28575">
+            <a:noFill/>
           </a:ln>
         </p:spPr>
         <p:style>
@@ -46388,8 +48813,8 @@
         </p:nvSpPr>
         <p:spPr>
           <a:xfrm>
-            <a:off x="1877100" y="-2"/>
-            <a:ext cx="1872000" cy="540001"/>
+            <a:off x="1867855" y="-2"/>
+            <a:ext cx="1890000" cy="540000"/>
           </a:xfrm>
           <a:prstGeom prst="roundRect">
             <a:avLst/>
@@ -46400,13 +48825,8 @@
               <a:lumOff val="60000"/>
             </a:schemeClr>
           </a:solidFill>
-          <a:ln>
-            <a:solidFill>
-              <a:schemeClr val="tx2">
-                <a:lumMod val="60000"/>
-                <a:lumOff val="40000"/>
-              </a:schemeClr>
-            </a:solidFill>
+          <a:ln w="28575">
+            <a:noFill/>
           </a:ln>
         </p:spPr>
         <p:style>
@@ -46459,8 +48879,8 @@
         </p:nvSpPr>
         <p:spPr>
           <a:xfrm>
-            <a:off x="3754200" y="-1"/>
-            <a:ext cx="1872000" cy="540001"/>
+            <a:off x="3752960" y="-1"/>
+            <a:ext cx="1890000" cy="540000"/>
           </a:xfrm>
           <a:prstGeom prst="roundRect">
             <a:avLst/>
@@ -46471,13 +48891,8 @@
               <a:lumOff val="60000"/>
             </a:schemeClr>
           </a:solidFill>
-          <a:ln>
-            <a:solidFill>
-              <a:schemeClr val="tx2">
-                <a:lumMod val="60000"/>
-                <a:lumOff val="40000"/>
-              </a:schemeClr>
-            </a:solidFill>
+          <a:ln w="28575">
+            <a:noFill/>
           </a:ln>
         </p:spPr>
         <p:style>
@@ -46530,8 +48945,8 @@
         </p:nvSpPr>
         <p:spPr>
           <a:xfrm>
-            <a:off x="5631300" y="-1"/>
-            <a:ext cx="4683600" cy="540001"/>
+            <a:off x="5638066" y="-1"/>
+            <a:ext cx="4680000" cy="540000"/>
           </a:xfrm>
           <a:prstGeom prst="roundRect">
             <a:avLst/>
@@ -46539,13 +48954,8 @@
           <a:solidFill>
             <a:schemeClr val="accent1"/>
           </a:solidFill>
-          <a:ln>
-            <a:solidFill>
-              <a:schemeClr val="tx2">
-                <a:lumMod val="60000"/>
-                <a:lumOff val="40000"/>
-              </a:schemeClr>
-            </a:solidFill>
+          <a:ln w="28575">
+            <a:noFill/>
           </a:ln>
         </p:spPr>
         <p:style>
@@ -46572,7 +48982,7 @@
           <a:p>
             <a:pPr algn="ctr"/>
             <a:r>
-              <a:rPr lang="en-US" sz="1600" dirty="0">
+              <a:rPr lang="en-US" sz="2000" b="1" dirty="0">
                 <a:solidFill>
                   <a:schemeClr val="bg1"/>
                 </a:solidFill>
@@ -46598,8 +49008,8 @@
         </p:nvSpPr>
         <p:spPr>
           <a:xfrm>
-            <a:off x="10320000" y="-1"/>
-            <a:ext cx="1872000" cy="540001"/>
+            <a:off x="10313172" y="-2"/>
+            <a:ext cx="1890000" cy="540000"/>
           </a:xfrm>
           <a:prstGeom prst="roundRect">
             <a:avLst/>
@@ -46610,13 +49020,8 @@
               <a:lumOff val="60000"/>
             </a:schemeClr>
           </a:solidFill>
-          <a:ln>
-            <a:solidFill>
-              <a:schemeClr val="tx2">
-                <a:lumMod val="60000"/>
-                <a:lumOff val="40000"/>
-              </a:schemeClr>
-            </a:solidFill>
+          <a:ln w="28575">
+            <a:noFill/>
           </a:ln>
         </p:spPr>
         <p:style>
@@ -46665,9 +49070,18 @@
   <p:clrMapOvr>
     <a:masterClrMapping/>
   </p:clrMapOvr>
-  <p:transition>
-    <p:fade/>
-  </p:transition>
+  <mc:AlternateContent xmlns:mc="http://schemas.openxmlformats.org/markup-compatibility/2006">
+    <mc:Choice xmlns:p159="http://schemas.microsoft.com/office/powerpoint/2015/09/main" Requires="p159">
+      <p:transition xmlns:p14="http://schemas.microsoft.com/office/powerpoint/2010/main" spd="slow" p14:dur="2000">
+        <p159:morph option="byObject"/>
+      </p:transition>
+    </mc:Choice>
+    <mc:Fallback>
+      <p:transition spd="slow">
+        <p:fade/>
+      </p:transition>
+    </mc:Fallback>
+  </mc:AlternateContent>
 </p:sld>
 </file>
 
@@ -46800,8 +49214,8 @@
         </p:nvSpPr>
         <p:spPr>
           <a:xfrm>
-            <a:off x="7508400" y="0"/>
-            <a:ext cx="4683600" cy="540001"/>
+            <a:off x="7521300" y="0"/>
+            <a:ext cx="4680000" cy="540000"/>
           </a:xfrm>
           <a:prstGeom prst="roundRect">
             <a:avLst/>
@@ -46809,13 +49223,8 @@
           <a:solidFill>
             <a:schemeClr val="accent1"/>
           </a:solidFill>
-          <a:ln>
-            <a:solidFill>
-              <a:schemeClr val="tx2">
-                <a:lumMod val="60000"/>
-                <a:lumOff val="40000"/>
-              </a:schemeClr>
-            </a:solidFill>
+          <a:ln w="28575">
+            <a:noFill/>
           </a:ln>
         </p:spPr>
         <p:style>
@@ -46842,7 +49251,7 @@
           <a:p>
             <a:pPr algn="ctr"/>
             <a:r>
-              <a:rPr lang="en-US" sz="1600" dirty="0">
+              <a:rPr lang="en-US" sz="2000" b="1" dirty="0">
                 <a:solidFill>
                   <a:schemeClr val="bg1"/>
                 </a:solidFill>
@@ -46869,7 +49278,7 @@
         <p:spPr>
           <a:xfrm>
             <a:off x="0" y="0"/>
-            <a:ext cx="1872000" cy="540000"/>
+            <a:ext cx="1890000" cy="540000"/>
           </a:xfrm>
           <a:prstGeom prst="roundRect">
             <a:avLst/>
@@ -46880,13 +49289,8 @@
               <a:lumOff val="60000"/>
             </a:schemeClr>
           </a:solidFill>
-          <a:ln>
-            <a:solidFill>
-              <a:schemeClr val="tx2">
-                <a:lumMod val="60000"/>
-                <a:lumOff val="40000"/>
-              </a:schemeClr>
-            </a:solidFill>
+          <a:ln w="28575">
+            <a:noFill/>
           </a:ln>
         </p:spPr>
         <p:style>
@@ -46939,8 +49343,8 @@
         </p:nvSpPr>
         <p:spPr>
           <a:xfrm>
-            <a:off x="1877100" y="0"/>
-            <a:ext cx="1872000" cy="540001"/>
+            <a:off x="1880325" y="0"/>
+            <a:ext cx="1890000" cy="540000"/>
           </a:xfrm>
           <a:prstGeom prst="roundRect">
             <a:avLst/>
@@ -46951,13 +49355,8 @@
               <a:lumOff val="60000"/>
             </a:schemeClr>
           </a:solidFill>
-          <a:ln>
-            <a:solidFill>
-              <a:schemeClr val="tx2">
-                <a:lumMod val="60000"/>
-                <a:lumOff val="40000"/>
-              </a:schemeClr>
-            </a:solidFill>
+          <a:ln w="28575">
+            <a:noFill/>
           </a:ln>
         </p:spPr>
         <p:style>
@@ -47010,8 +49409,8 @@
         </p:nvSpPr>
         <p:spPr>
           <a:xfrm>
-            <a:off x="3754200" y="0"/>
-            <a:ext cx="1872000" cy="540001"/>
+            <a:off x="3760650" y="0"/>
+            <a:ext cx="1890000" cy="540000"/>
           </a:xfrm>
           <a:prstGeom prst="roundRect">
             <a:avLst/>
@@ -47022,13 +49421,8 @@
               <a:lumOff val="60000"/>
             </a:schemeClr>
           </a:solidFill>
-          <a:ln>
-            <a:solidFill>
-              <a:schemeClr val="tx2">
-                <a:lumMod val="60000"/>
-                <a:lumOff val="40000"/>
-              </a:schemeClr>
-            </a:solidFill>
+          <a:ln w="28575">
+            <a:noFill/>
           </a:ln>
         </p:spPr>
         <p:style>
@@ -47081,8 +49475,8 @@
         </p:nvSpPr>
         <p:spPr>
           <a:xfrm>
-            <a:off x="5631300" y="0"/>
-            <a:ext cx="1872000" cy="540001"/>
+            <a:off x="5640975" y="0"/>
+            <a:ext cx="1890000" cy="540000"/>
           </a:xfrm>
           <a:prstGeom prst="roundRect">
             <a:avLst/>
@@ -47093,13 +49487,8 @@
               <a:lumOff val="60000"/>
             </a:schemeClr>
           </a:solidFill>
-          <a:ln>
-            <a:solidFill>
-              <a:schemeClr val="tx2">
-                <a:lumMod val="60000"/>
-                <a:lumOff val="40000"/>
-              </a:schemeClr>
-            </a:solidFill>
+          <a:ln w="28575">
+            <a:noFill/>
           </a:ln>
         </p:spPr>
         <p:style>
@@ -47148,9 +49537,18 @@
   <p:clrMapOvr>
     <a:masterClrMapping/>
   </p:clrMapOvr>
-  <p:transition>
-    <p:fade/>
-  </p:transition>
+  <mc:AlternateContent xmlns:mc="http://schemas.openxmlformats.org/markup-compatibility/2006">
+    <mc:Choice xmlns:p159="http://schemas.microsoft.com/office/powerpoint/2015/09/main" Requires="p159">
+      <p:transition xmlns:p14="http://schemas.microsoft.com/office/powerpoint/2010/main" spd="slow" p14:dur="2000">
+        <p159:morph option="byObject"/>
+      </p:transition>
+    </mc:Choice>
+    <mc:Fallback>
+      <p:transition spd="slow">
+        <p:fade/>
+      </p:transition>
+    </mc:Fallback>
+  </mc:AlternateContent>
 </p:sld>
 </file>
 

</xml_diff>